<commit_message>
vault backup: 2026-04-12 17:55:23
</commit_message>
<xml_diff>
--- a/99_System/.scratch/imai-presentation/Imai_Meeting_20260413.pptx
+++ b/99_System/.scratch/imai-presentation/Imai_Meeting_20260413.pptx
@@ -8,7 +8,7 @@
     <p:notesMasterId r:id="rId7"/>
   </p:notesMasterIdLst>
   <p:sldIdLst>
-    <p:sldId id="268" r:id="rId2"/>
+    <p:sldId id="275" r:id="rId2"/>
     <p:sldId id="262" r:id="rId3"/>
     <p:sldId id="263" r:id="rId4"/>
     <p:sldId id="264" r:id="rId5"/>
@@ -300,49 +300,66 @@
           <a:lstStyle/>
           <a:p>
             <a:r>
+              <a:rPr dirty="0"/>
               <a:t>TALKING POINTS:</a:t>
             </a:r>
           </a:p>
           <a:p>
             <a:r>
+              <a:rPr dirty="0"/>
               <a:t>- Shell evolution is the fundamental question: how does nuclear structure change as we add neutrons far from stability?</a:t>
             </a:r>
           </a:p>
           <a:p>
             <a:r>
+              <a:rPr dirty="0"/>
               <a:t>- Magic numbers we learned (2,8,20,28,50,82,126) aren't universal -- tensor force monopole reshuffles levels (Otsuka et al., RMP 2020).</a:t>
             </a:r>
           </a:p>
           <a:p>
             <a:r>
+              <a:rPr dirty="0"/>
               <a:t>- Direct reactions are the tool: single-step, ~10^-22 s, probe nuclear surface. DWBA analysis extracts C2S.</a:t>
             </a:r>
           </a:p>
           <a:p>
             <a:r>
+              <a:rPr dirty="0"/>
               <a:t>- Active-target TPCs solve the luminosity problem for exotic beam experiments at facilities like HIRFL-RIBLL (IMP) and RIKEN RIBF.</a:t>
             </a:r>
           </a:p>
           <a:p>
             <a:r>
-              <a:t>- But the killer problem is PID: you need clean channel identification to gate on the correct reaction. Classical dE-E cuts struggle with overlapping Bethe-Bloch curves, especially for similar A/Z species.</a:t>
-            </a:r>
-          </a:p>
-          <a:p>
-            <a:r>
+              <a:rPr dirty="0"/>
+              <a:t>- But the killer problem is PID: you need clean channel identification to gate on the correct reaction. Classical </a:t>
+            </a:r>
+            <a:r>
+              <a:rPr dirty="0" err="1"/>
+              <a:t>dE</a:t>
+            </a:r>
+            <a:r>
+              <a:rPr dirty="0"/>
+              <a:t>-E cuts struggle with overlapping Bethe-Bloch curves, especially for similar A/Z species.</a:t>
+            </a:r>
+          </a:p>
+          <a:p>
+            <a:r>
+              <a:rPr dirty="0"/>
               <a:t>- This motivates our ML approach.</a:t>
             </a:r>
           </a:p>
           <a:p>
-            <a:endParaRPr/>
-          </a:p>
-          <a:p>
-            <a:r>
+            <a:endParaRPr dirty="0"/>
+          </a:p>
+          <a:p>
+            <a:r>
+              <a:rPr dirty="0"/>
               <a:t>FIGURE: MATE-TPC schematic from NST paper (pad plane + GEM + field cage).</a:t>
             </a:r>
           </a:p>
           <a:p>
             <a:r>
+              <a:rPr dirty="0"/>
               <a:t>Figure path: D:\obsidian\OrbitOS\50_Resources\Physics\literature\MLforPhysics\NST-ML-12C12C-MATE\_page_3_Figure_9.jpeg</a:t>
             </a:r>
           </a:p>
@@ -3933,7 +3950,7 @@
         <p:spPr>
           <a:xfrm>
             <a:off x="640080" y="96012"/>
-            <a:ext cx="10911535" cy="366254"/>
+            <a:ext cx="10911535" cy="523220"/>
           </a:xfrm>
           <a:prstGeom prst="rect">
             <a:avLst/>
@@ -3956,7 +3973,7 @@
             </a:pPr>
             <a:r>
               <a:rPr lang="en-US" dirty="0"/>
-              <a:t>Physics Motivation: Nuclear Structure Through Direct Reactions</a:t>
+              <a:t>Physics Motivation: Direct &amp; Surrogate Reactions</a:t>
             </a:r>
           </a:p>
         </p:txBody>
@@ -4050,8 +4067,8 @@
         </p:nvSpPr>
         <p:spPr>
           <a:xfrm>
-            <a:off x="640080" y="1234440"/>
-            <a:ext cx="6858000" cy="3339376"/>
+            <a:off x="254000" y="917124"/>
+            <a:ext cx="6604000" cy="3339376"/>
           </a:xfrm>
           <a:prstGeom prst="rect">
             <a:avLst/>
@@ -4253,10 +4270,369 @@
           </a:p>
         </p:txBody>
       </p:sp>
+      <p:sp>
+        <p:nvSpPr>
+          <p:cNvPr id="30" name="DiagramTitle"/>
+          <p:cNvSpPr txBox="1"/>
+          <p:nvPr/>
+        </p:nvSpPr>
+        <p:spPr>
+          <a:xfrm>
+            <a:off x="6858000" y="889000"/>
+            <a:ext cx="4191000" cy="330200"/>
+          </a:xfrm>
+          <a:prstGeom prst="rect">
+            <a:avLst/>
+          </a:prstGeom>
+          <a:noFill/>
+          <a:ln>
+            <a:noFill/>
+          </a:ln>
+        </p:spPr>
+        <p:txBody>
+          <a:bodyPr wrap="square" anchor="ctr"/>
+          <a:lstStyle/>
+          <a:p>
+            <a:pPr algn="ctr"/>
+            <a:r>
+              <a:rPr lang="en-US" sz="1500" b="1" dirty="0">
+                <a:solidFill>
+                  <a:srgbClr val="174994"/>
+                </a:solidFill>
+                <a:latin typeface="Times New Roman"/>
+              </a:rPr>
+              <a:t>Surrogate Reaction Method</a:t>
+            </a:r>
+          </a:p>
+        </p:txBody>
+      </p:sp>
+      <p:sp>
+        <p:nvSpPr>
+          <p:cNvPr id="45" name="Formula"/>
+          <p:cNvSpPr txBox="1"/>
+          <p:nvPr/>
+        </p:nvSpPr>
+        <p:spPr>
+          <a:xfrm>
+            <a:off x="6896100" y="5207000"/>
+            <a:ext cx="4699000" cy="279400"/>
+          </a:xfrm>
+          <a:prstGeom prst="rect">
+            <a:avLst/>
+          </a:prstGeom>
+          <a:noFill/>
+          <a:ln>
+            <a:noFill/>
+          </a:ln>
+        </p:spPr>
+        <p:txBody>
+          <a:bodyPr wrap="square" anchor="ctr"/>
+          <a:lstStyle/>
+          <a:p>
+            <a:pPr algn="ctr"/>
+            <a:r>
+              <a:rPr lang="en-US" sz="1600" i="1" dirty="0">
+                <a:solidFill>
+                  <a:srgbClr val="2D2D2D"/>
+                </a:solidFill>
+                <a:latin typeface="Times New Roman"/>
+              </a:rPr>
+              <a:t>σ</a:t>
+            </a:r>
+            <a:r>
+              <a:rPr lang="en-US" sz="1600" dirty="0">
+                <a:solidFill>
+                  <a:srgbClr val="2D2D2D"/>
+                </a:solidFill>
+                <a:latin typeface="Times New Roman"/>
+              </a:rPr>
+              <a:t>(n,x) = ∑</a:t>
+            </a:r>
+            <a:r>
+              <a:rPr lang="en-US" sz="1600" baseline="-25000" dirty="0">
+                <a:solidFill>
+                  <a:srgbClr val="2D2D2D"/>
+                </a:solidFill>
+                <a:latin typeface="Times New Roman"/>
+              </a:rPr>
+              <a:t>J,π</a:t>
+            </a:r>
+            <a:r>
+              <a:rPr lang="en-US" sz="1600" dirty="0">
+                <a:solidFill>
+                  <a:srgbClr val="2D2D2D"/>
+                </a:solidFill>
+                <a:latin typeface="Times New Roman"/>
+              </a:rPr>
+              <a:t> </a:t>
+            </a:r>
+            <a:r>
+              <a:rPr lang="en-US" sz="1600" i="1" dirty="0">
+                <a:solidFill>
+                  <a:srgbClr val="2D2D2D"/>
+                </a:solidFill>
+                <a:latin typeface="Times New Roman"/>
+              </a:rPr>
+              <a:t>σ</a:t>
+            </a:r>
+            <a:r>
+              <a:rPr lang="en-US" sz="1600" baseline="-25000" dirty="0">
+                <a:solidFill>
+                  <a:srgbClr val="2D2D2D"/>
+                </a:solidFill>
+                <a:latin typeface="Times New Roman"/>
+              </a:rPr>
+              <a:t>CN</a:t>
+            </a:r>
+            <a:r>
+              <a:rPr lang="en-US" sz="1600" dirty="0">
+                <a:solidFill>
+                  <a:srgbClr val="2D2D2D"/>
+                </a:solidFill>
+                <a:latin typeface="Times New Roman"/>
+              </a:rPr>
+              <a:t>(n+A; </a:t>
+            </a:r>
+            <a:r>
+              <a:rPr lang="en-US" sz="1600" i="1" dirty="0">
+                <a:solidFill>
+                  <a:srgbClr val="2D2D2D"/>
+                </a:solidFill>
+                <a:latin typeface="Times New Roman"/>
+              </a:rPr>
+              <a:t>J</a:t>
+            </a:r>
+            <a:r>
+              <a:rPr lang="en-US" sz="1600" baseline="30000" dirty="0">
+                <a:solidFill>
+                  <a:srgbClr val="2D2D2D"/>
+                </a:solidFill>
+                <a:latin typeface="Times New Roman"/>
+              </a:rPr>
+              <a:t>π</a:t>
+            </a:r>
+            <a:r>
+              <a:rPr lang="en-US" sz="1600" dirty="0">
+                <a:solidFill>
+                  <a:srgbClr val="2D2D2D"/>
+                </a:solidFill>
+                <a:latin typeface="Times New Roman"/>
+              </a:rPr>
+              <a:t>) × </a:t>
+            </a:r>
+            <a:r>
+              <a:rPr lang="en-US" sz="1600" i="1" dirty="0">
+                <a:solidFill>
+                  <a:srgbClr val="2D2D2D"/>
+                </a:solidFill>
+                <a:latin typeface="Times New Roman"/>
+              </a:rPr>
+              <a:t>P</a:t>
+            </a:r>
+            <a:r>
+              <a:rPr lang="en-US" sz="1600" baseline="-25000" dirty="0">
+                <a:solidFill>
+                  <a:srgbClr val="2D2D2D"/>
+                </a:solidFill>
+                <a:latin typeface="Times New Roman"/>
+              </a:rPr>
+              <a:t>decay</a:t>
+            </a:r>
+            <a:r>
+              <a:rPr lang="en-US" sz="1600" dirty="0">
+                <a:solidFill>
+                  <a:srgbClr val="2D2D2D"/>
+                </a:solidFill>
+                <a:latin typeface="Times New Roman"/>
+              </a:rPr>
+              <a:t>(B*; </a:t>
+            </a:r>
+            <a:r>
+              <a:rPr lang="en-US" sz="1600" i="1" dirty="0">
+                <a:solidFill>
+                  <a:srgbClr val="2D2D2D"/>
+                </a:solidFill>
+                <a:latin typeface="Times New Roman"/>
+              </a:rPr>
+              <a:t>J</a:t>
+            </a:r>
+            <a:r>
+              <a:rPr lang="en-US" sz="1600" baseline="30000" dirty="0">
+                <a:solidFill>
+                  <a:srgbClr val="2D2D2D"/>
+                </a:solidFill>
+                <a:latin typeface="Times New Roman"/>
+              </a:rPr>
+              <a:t>π</a:t>
+            </a:r>
+            <a:r>
+              <a:rPr lang="en-US" sz="1600" dirty="0">
+                <a:solidFill>
+                  <a:srgbClr val="2D2D2D"/>
+                </a:solidFill>
+                <a:latin typeface="Times New Roman"/>
+              </a:rPr>
+              <a:t>)</a:t>
+            </a:r>
+          </a:p>
+        </p:txBody>
+      </p:sp>
+      <p:sp>
+        <p:nvSpPr>
+          <p:cNvPr id="46" name="Ref"/>
+          <p:cNvSpPr txBox="1"/>
+          <p:nvPr/>
+        </p:nvSpPr>
+        <p:spPr>
+          <a:xfrm>
+            <a:off x="6896100" y="5511800"/>
+            <a:ext cx="4699000" cy="254000"/>
+          </a:xfrm>
+          <a:prstGeom prst="rect">
+            <a:avLst/>
+          </a:prstGeom>
+          <a:noFill/>
+          <a:ln>
+            <a:noFill/>
+          </a:ln>
+        </p:spPr>
+        <p:txBody>
+          <a:bodyPr wrap="square" anchor="ctr"/>
+          <a:lstStyle/>
+          <a:p>
+            <a:pPr algn="ctr"/>
+            <a:r>
+              <a:rPr lang="en-US" sz="1200" i="1" dirty="0">
+                <a:solidFill>
+                  <a:srgbClr val="888888"/>
+                </a:solidFill>
+                <a:latin typeface="Times New Roman"/>
+              </a:rPr>
+              <a:t>Escher et al., Rev. Mod. Phys. 84, 353 (2012)</a:t>
+            </a:r>
+          </a:p>
+        </p:txBody>
+      </p:sp>
+      <p:pic>
+        <p:nvPicPr>
+          <p:cNvPr id="10" name="Picture 9">
+            <a:extLst>
+              <a:ext uri="{FF2B5EF4-FFF2-40B4-BE49-F238E27FC236}">
+                <a16:creationId xmlns:a16="http://schemas.microsoft.com/office/drawing/2014/main" id="{1AC06186-F23E-1901-2EF8-728DB3B665CA}"/>
+              </a:ext>
+            </a:extLst>
+          </p:cNvPr>
+          <p:cNvPicPr>
+            <a:picLocks noChangeAspect="1"/>
+          </p:cNvPicPr>
+          <p:nvPr/>
+        </p:nvPicPr>
+        <p:blipFill>
+          <a:blip r:embed="rId3"/>
+          <a:stretch>
+            <a:fillRect/>
+          </a:stretch>
+        </p:blipFill>
+        <p:spPr>
+          <a:xfrm>
+            <a:off x="7223601" y="1219200"/>
+            <a:ext cx="4000500" cy="3911600"/>
+          </a:xfrm>
+          <a:prstGeom prst="rect">
+            <a:avLst/>
+          </a:prstGeom>
+        </p:spPr>
+      </p:pic>
+      <p:sp>
+        <p:nvSpPr>
+          <p:cNvPr id="7" name="Caveat">
+            <a:extLst>
+              <a:ext uri="{FF2B5EF4-FFF2-40B4-BE49-F238E27FC236}">
+                <a16:creationId xmlns:a16="http://schemas.microsoft.com/office/drawing/2014/main" id="{FBA7673A-85E8-44F2-BF05-8746B6820506}"/>
+              </a:ext>
+            </a:extLst>
+          </p:cNvPr>
+          <p:cNvSpPr txBox="1"/>
+          <p:nvPr/>
+        </p:nvSpPr>
+        <p:spPr>
+          <a:xfrm>
+            <a:off x="6896100" y="5791200"/>
+            <a:ext cx="4699000" cy="400110"/>
+          </a:xfrm>
+          <a:prstGeom prst="rect">
+            <a:avLst/>
+          </a:prstGeom>
+          <a:noFill/>
+        </p:spPr>
+        <p:txBody>
+          <a:bodyPr vertOverflow="overflow" vert="horz" wrap="square" rtlCol="0" anchor="t">
+            <a:spAutoFit/>
+          </a:bodyPr>
+          <a:lstStyle/>
+          <a:p>
+            <a:pPr algn="ctr"/>
+            <a:r>
+              <a:rPr lang="en-US" sz="1000" i="1" dirty="0">
+                <a:solidFill>
+                  <a:srgbClr val="C04040"/>
+                </a:solidFill>
+                <a:latin typeface="Times New Roman"/>
+              </a:rPr>
+              <a:t>⚠ Diagram assumes W-E limit: P</a:t>
+            </a:r>
+            <a:r>
+              <a:rPr lang="en-US" sz="1000" i="1" baseline="-25000" dirty="0">
+                <a:solidFill>
+                  <a:srgbClr val="C04040"/>
+                </a:solidFill>
+                <a:latin typeface="Times New Roman"/>
+              </a:rPr>
+              <a:t>decay</a:t>
+            </a:r>
+            <a:r>
+              <a:rPr lang="en-US" sz="1000" i="1" dirty="0">
+                <a:solidFill>
+                  <a:srgbClr val="C04040"/>
+                </a:solidFill>
+                <a:latin typeface="Times New Roman"/>
+              </a:rPr>
+              <a:t> independent of J</a:t>
+            </a:r>
+            <a:r>
+              <a:rPr lang="en-US" sz="1000" i="1" baseline="30000" dirty="0">
+                <a:solidFill>
+                  <a:srgbClr val="C04040"/>
+                </a:solidFill>
+                <a:latin typeface="Times New Roman"/>
+              </a:rPr>
+              <a:t>π</a:t>
+            </a:r>
+            <a:r>
+              <a:rPr lang="en-US" sz="1000" i="1" dirty="0">
+                <a:solidFill>
+                  <a:srgbClr val="C04040"/>
+                </a:solidFill>
+                <a:latin typeface="Times New Roman"/>
+              </a:rPr>
+              <a:t> — surrogates populate different J</a:t>
+            </a:r>
+            <a:r>
+              <a:rPr lang="en-US" sz="1000" i="1" baseline="30000" dirty="0">
+                <a:solidFill>
+                  <a:srgbClr val="C04040"/>
+                </a:solidFill>
+                <a:latin typeface="Times New Roman"/>
+              </a:rPr>
+              <a:t>π</a:t>
+            </a:r>
+          </a:p>
+        </p:txBody>
+      </p:sp>
     </p:spTree>
     <p:extLst>
       <p:ext uri="{BB962C8B-B14F-4D97-AF65-F5344CB8AC3E}">
-        <p14:creationId xmlns:p14="http://schemas.microsoft.com/office/powerpoint/2010/main" val="79646459"/>
+        <p14:creationId xmlns:p14="http://schemas.microsoft.com/office/powerpoint/2010/main" val="1497468000"/>
       </p:ext>
     </p:extLst>
   </p:cSld>

</xml_diff>

<commit_message>
vault backup: 2026-04-12 18:27:16
</commit_message>
<xml_diff>
--- a/99_System/.scratch/imai-presentation/Imai_Meeting_20260413.pptx
+++ b/99_System/.scratch/imai-presentation/Imai_Meeting_20260413.pptx
@@ -8,7 +8,7 @@
     <p:notesMasterId r:id="rId7"/>
   </p:notesMasterIdLst>
   <p:sldIdLst>
-    <p:sldId id="275" r:id="rId2"/>
+    <p:sldId id="287" r:id="rId2"/>
     <p:sldId id="262" r:id="rId3"/>
     <p:sldId id="263" r:id="rId4"/>
     <p:sldId id="264" r:id="rId5"/>
@@ -4061,217 +4061,6 @@
       </p:sp>
       <p:sp>
         <p:nvSpPr>
-          <p:cNvPr id="6" name="TextBox 5"/>
-          <p:cNvSpPr txBox="1"/>
-          <p:nvPr/>
-        </p:nvSpPr>
-        <p:spPr>
-          <a:xfrm>
-            <a:off x="254000" y="917124"/>
-            <a:ext cx="6604000" cy="3339376"/>
-          </a:xfrm>
-          <a:prstGeom prst="rect">
-            <a:avLst/>
-          </a:prstGeom>
-          <a:noFill/>
-        </p:spPr>
-        <p:txBody>
-          <a:bodyPr wrap="square">
-            <a:spAutoFit/>
-          </a:bodyPr>
-          <a:lstStyle/>
-          <a:p>
-            <a:pPr>
-              <a:spcAft>
-                <a:spcPts val="600"/>
-              </a:spcAft>
-              <a:defRPr sz="1600" b="1">
-                <a:solidFill>
-                  <a:srgbClr val="174994"/>
-                </a:solidFill>
-                <a:latin typeface="Times New Roman"/>
-              </a:defRPr>
-            </a:pPr>
-            <a:r>
-              <a:rPr lang="en-US" dirty="0"/>
-              <a:t>Shell evolution far from stability</a:t>
-            </a:r>
-          </a:p>
-          <a:p>
-            <a:pPr lvl="1">
-              <a:spcAft>
-                <a:spcPts val="600"/>
-              </a:spcAft>
-              <a:defRPr sz="1600">
-                <a:solidFill>
-                  <a:srgbClr val="2D2D2D"/>
-                </a:solidFill>
-                <a:latin typeface="Times New Roman"/>
-              </a:defRPr>
-            </a:pPr>
-            <a:r>
-              <a:rPr lang="en-US" dirty="0"/>
-              <a:t>Classic magic numbers erode in neutron-rich nuclei; tensor </a:t>
-            </a:r>
-            <a:r>
-              <a:rPr lang="en-US" i="1" dirty="0"/>
-              <a:t>NN</a:t>
-            </a:r>
-            <a:r>
-              <a:rPr lang="en-US" dirty="0"/>
-              <a:t> force reshapes single-particle levels</a:t>
-            </a:r>
-          </a:p>
-          <a:p>
-            <a:pPr>
-              <a:spcAft>
-                <a:spcPts val="600"/>
-              </a:spcAft>
-              <a:defRPr sz="1600" b="1">
-                <a:solidFill>
-                  <a:srgbClr val="174994"/>
-                </a:solidFill>
-                <a:latin typeface="Times New Roman"/>
-              </a:defRPr>
-            </a:pPr>
-            <a:r>
-              <a:rPr lang="en-US" dirty="0"/>
-              <a:t>Direct reactions as the spectroscopic tool</a:t>
-            </a:r>
-          </a:p>
-          <a:p>
-            <a:pPr lvl="1">
-              <a:spcAft>
-                <a:spcPts val="600"/>
-              </a:spcAft>
-              <a:defRPr sz="1600">
-                <a:solidFill>
-                  <a:srgbClr val="2D2D2D"/>
-                </a:solidFill>
-                <a:latin typeface="Times New Roman"/>
-              </a:defRPr>
-            </a:pPr>
-            <a:r>
-              <a:rPr lang="en-US" dirty="0"/>
-              <a:t>(d,p) / (p,d) at 10–30 MeV/u in inverse kinematics → </a:t>
-            </a:r>
-            <a:r>
-              <a:rPr lang="en-US" i="1" dirty="0"/>
-              <a:t>C</a:t>
-            </a:r>
-            <a:r>
-              <a:rPr lang="en-US" baseline="30000" dirty="0"/>
-              <a:t>2</a:t>
-            </a:r>
-            <a:r>
-              <a:rPr lang="en-US" i="1" dirty="0"/>
-              <a:t>S</a:t>
-            </a:r>
-            <a:r>
-              <a:rPr lang="en-US" dirty="0"/>
-              <a:t>, </a:t>
-            </a:r>
-            <a:r>
-              <a:rPr lang="en-US" i="1" dirty="0"/>
-              <a:t>J</a:t>
-            </a:r>
-            <a:r>
-              <a:rPr lang="en-US" baseline="30000" dirty="0"/>
-              <a:t>π</a:t>
-            </a:r>
-            <a:r>
-              <a:rPr lang="en-US" dirty="0"/>
-              <a:t>, occupancies</a:t>
-            </a:r>
-          </a:p>
-          <a:p>
-            <a:pPr>
-              <a:spcAft>
-                <a:spcPts val="600"/>
-              </a:spcAft>
-              <a:defRPr sz="1600" b="1">
-                <a:solidFill>
-                  <a:srgbClr val="174994"/>
-                </a:solidFill>
-                <a:latin typeface="Times New Roman"/>
-              </a:defRPr>
-            </a:pPr>
-            <a:r>
-              <a:rPr lang="en-US" dirty="0"/>
-              <a:t>Active-target TPCs: luminosity without resolution loss</a:t>
-            </a:r>
-          </a:p>
-          <a:p>
-            <a:pPr lvl="1">
-              <a:spcAft>
-                <a:spcPts val="600"/>
-              </a:spcAft>
-              <a:defRPr sz="1600">
-                <a:solidFill>
-                  <a:srgbClr val="2D2D2D"/>
-                </a:solidFill>
-                <a:latin typeface="Times New Roman"/>
-              </a:defRPr>
-            </a:pPr>
-            <a:r>
-              <a:rPr lang="en-US" dirty="0"/>
-              <a:t>Gas = target → thick-target statistics, full kinematics, near-unity efficiency for low-energy recoils</a:t>
-            </a:r>
-          </a:p>
-          <a:p>
-            <a:pPr>
-              <a:spcAft>
-                <a:spcPts val="600"/>
-              </a:spcAft>
-              <a:defRPr sz="1600" b="1">
-                <a:solidFill>
-                  <a:srgbClr val="174994"/>
-                </a:solidFill>
-                <a:latin typeface="Times New Roman"/>
-              </a:defRPr>
-            </a:pPr>
-            <a:r>
-              <a:rPr lang="en-US" dirty="0"/>
-              <a:t>The bottleneck: particle identification in the TPC</a:t>
-            </a:r>
-          </a:p>
-          <a:p>
-            <a:pPr lvl="1">
-              <a:spcAft>
-                <a:spcPts val="600"/>
-              </a:spcAft>
-              <a:defRPr sz="1600">
-                <a:solidFill>
-                  <a:srgbClr val="2D2D2D"/>
-                </a:solidFill>
-                <a:latin typeface="Times New Roman"/>
-              </a:defRPr>
-            </a:pPr>
-            <a:r>
-              <a:rPr lang="en-US" dirty="0"/>
-              <a:t>Overlapping d</a:t>
-            </a:r>
-            <a:r>
-              <a:rPr lang="en-US" i="1" dirty="0"/>
-              <a:t>E</a:t>
-            </a:r>
-            <a:r>
-              <a:rPr lang="en-US" dirty="0"/>
-              <a:t>/d</a:t>
-            </a:r>
-            <a:r>
-              <a:rPr lang="en-US" i="1" dirty="0"/>
-              <a:t>x</a:t>
-            </a:r>
-            <a:r>
-              <a:rPr lang="en-US" dirty="0"/>
-              <a:t> bands, pile-up, orders-of-magnitude dynamic range → ML-based PID required</a:t>
-            </a:r>
-          </a:p>
-        </p:txBody>
-      </p:sp>
-      <p:sp>
-        <p:nvSpPr>
           <p:cNvPr id="30" name="DiagramTitle"/>
           <p:cNvSpPr txBox="1"/>
           <p:nvPr/>
@@ -4314,7 +4103,7 @@
         </p:nvSpPr>
         <p:spPr>
           <a:xfrm>
-            <a:off x="6896100" y="5207000"/>
+            <a:off x="6896100" y="5393447"/>
             <a:ext cx="4699000" cy="279400"/>
           </a:xfrm>
           <a:prstGeom prst="rect">
@@ -4485,7 +4274,7 @@
         </p:nvSpPr>
         <p:spPr>
           <a:xfrm>
-            <a:off x="6896100" y="5511800"/>
+            <a:off x="6896100" y="5698247"/>
             <a:ext cx="4699000" cy="254000"/>
           </a:xfrm>
           <a:prstGeom prst="rect">
@@ -4545,10 +4334,524 @@
       </p:pic>
       <p:sp>
         <p:nvSpPr>
-          <p:cNvPr id="7" name="Caveat">
+          <p:cNvPr id="8" name="Oval 7">
             <a:extLst>
               <a:ext uri="{FF2B5EF4-FFF2-40B4-BE49-F238E27FC236}">
-                <a16:creationId xmlns:a16="http://schemas.microsoft.com/office/drawing/2014/main" id="{FBA7673A-85E8-44F2-BF05-8746B6820506}"/>
+                <a16:creationId xmlns:a16="http://schemas.microsoft.com/office/drawing/2014/main" id="{C2B06D01-DC5E-4474-9882-93590E914CD6}"/>
+              </a:ext>
+            </a:extLst>
+          </p:cNvPr>
+          <p:cNvSpPr/>
+          <p:nvPr/>
+        </p:nvSpPr>
+        <p:spPr>
+          <a:xfrm>
+            <a:off x="254000" y="939800"/>
+            <a:ext cx="431800" cy="431800"/>
+          </a:xfrm>
+          <a:prstGeom prst="ellipse">
+            <a:avLst/>
+          </a:prstGeom>
+          <a:solidFill>
+            <a:srgbClr val="174994"/>
+          </a:solidFill>
+          <a:ln w="9525" cap="flat" cmpd="sng" algn="ctr">
+            <a:noFill/>
+            <a:prstDash val="solid"/>
+          </a:ln>
+        </p:spPr>
+        <p:style>
+          <a:lnRef idx="1">
+            <a:schemeClr val="accent1"/>
+          </a:lnRef>
+          <a:fillRef idx="3">
+            <a:schemeClr val="accent1"/>
+          </a:fillRef>
+          <a:effectRef idx="2">
+            <a:schemeClr val="accent1"/>
+          </a:effectRef>
+          <a:fontRef idx="minor">
+            <a:schemeClr val="lt1"/>
+          </a:fontRef>
+        </p:style>
+        <p:txBody>
+          <a:bodyPr vertOverflow="clip" horzOverflow="clip" wrap="none" rtlCol="0" anchor="ctr" anchorCtr="0">
+            <a:noAutofit/>
+          </a:bodyPr>
+          <a:lstStyle/>
+          <a:p>
+            <a:endParaRPr lang="en-US" dirty="0"/>
+          </a:p>
+        </p:txBody>
+      </p:sp>
+      <p:sp>
+        <p:nvSpPr>
+          <p:cNvPr id="9" name="Oval 8">
+            <a:extLst>
+              <a:ext uri="{FF2B5EF4-FFF2-40B4-BE49-F238E27FC236}">
+                <a16:creationId xmlns:a16="http://schemas.microsoft.com/office/drawing/2014/main" id="{A5DC444F-2DAD-4730-A01C-0CE49DD391E3}"/>
+              </a:ext>
+            </a:extLst>
+          </p:cNvPr>
+          <p:cNvSpPr/>
+          <p:nvPr/>
+        </p:nvSpPr>
+        <p:spPr>
+          <a:xfrm>
+            <a:off x="254000" y="2286000"/>
+            <a:ext cx="431800" cy="431800"/>
+          </a:xfrm>
+          <a:prstGeom prst="ellipse">
+            <a:avLst/>
+          </a:prstGeom>
+          <a:solidFill>
+            <a:srgbClr val="174994"/>
+          </a:solidFill>
+          <a:ln w="9525" cap="flat" cmpd="sng" algn="ctr">
+            <a:noFill/>
+            <a:prstDash val="solid"/>
+          </a:ln>
+        </p:spPr>
+        <p:style>
+          <a:lnRef idx="1">
+            <a:schemeClr val="accent1"/>
+          </a:lnRef>
+          <a:fillRef idx="3">
+            <a:schemeClr val="accent1"/>
+          </a:fillRef>
+          <a:effectRef idx="2">
+            <a:schemeClr val="accent1"/>
+          </a:effectRef>
+          <a:fontRef idx="minor">
+            <a:schemeClr val="lt1"/>
+          </a:fontRef>
+        </p:style>
+        <p:txBody>
+          <a:bodyPr vertOverflow="clip" horzOverflow="clip" wrap="none" rtlCol="0" anchor="ctr" anchorCtr="0">
+            <a:noAutofit/>
+          </a:bodyPr>
+          <a:lstStyle/>
+          <a:p>
+            <a:endParaRPr lang="en-US" dirty="0"/>
+          </a:p>
+        </p:txBody>
+      </p:sp>
+      <p:sp>
+        <p:nvSpPr>
+          <p:cNvPr id="11" name="Oval 10">
+            <a:extLst>
+              <a:ext uri="{FF2B5EF4-FFF2-40B4-BE49-F238E27FC236}">
+                <a16:creationId xmlns:a16="http://schemas.microsoft.com/office/drawing/2014/main" id="{35243E31-674B-458D-B94D-C0D83A5B3D4B}"/>
+              </a:ext>
+            </a:extLst>
+          </p:cNvPr>
+          <p:cNvSpPr/>
+          <p:nvPr/>
+        </p:nvSpPr>
+        <p:spPr>
+          <a:xfrm>
+            <a:off x="254000" y="3632200"/>
+            <a:ext cx="431800" cy="431800"/>
+          </a:xfrm>
+          <a:prstGeom prst="ellipse">
+            <a:avLst/>
+          </a:prstGeom>
+          <a:solidFill>
+            <a:srgbClr val="174994"/>
+          </a:solidFill>
+          <a:ln w="9525" cap="flat" cmpd="sng" algn="ctr">
+            <a:noFill/>
+            <a:prstDash val="solid"/>
+          </a:ln>
+        </p:spPr>
+        <p:style>
+          <a:lnRef idx="1">
+            <a:schemeClr val="accent1"/>
+          </a:lnRef>
+          <a:fillRef idx="3">
+            <a:schemeClr val="accent1"/>
+          </a:fillRef>
+          <a:effectRef idx="2">
+            <a:schemeClr val="accent1"/>
+          </a:effectRef>
+          <a:fontRef idx="minor">
+            <a:schemeClr val="lt1"/>
+          </a:fontRef>
+        </p:style>
+        <p:txBody>
+          <a:bodyPr vertOverflow="clip" horzOverflow="clip" wrap="none" rtlCol="0" anchor="ctr" anchorCtr="0">
+            <a:noAutofit/>
+          </a:bodyPr>
+          <a:lstStyle/>
+          <a:p>
+            <a:endParaRPr lang="en-US" dirty="0"/>
+          </a:p>
+        </p:txBody>
+      </p:sp>
+      <p:sp>
+        <p:nvSpPr>
+          <p:cNvPr id="12" name="Oval 11">
+            <a:extLst>
+              <a:ext uri="{FF2B5EF4-FFF2-40B4-BE49-F238E27FC236}">
+                <a16:creationId xmlns:a16="http://schemas.microsoft.com/office/drawing/2014/main" id="{6057F8D4-8D22-4931-A0FD-E9E6E2446B3C}"/>
+              </a:ext>
+            </a:extLst>
+          </p:cNvPr>
+          <p:cNvSpPr/>
+          <p:nvPr/>
+        </p:nvSpPr>
+        <p:spPr>
+          <a:xfrm>
+            <a:off x="254000" y="4978400"/>
+            <a:ext cx="431800" cy="431800"/>
+          </a:xfrm>
+          <a:prstGeom prst="ellipse">
+            <a:avLst/>
+          </a:prstGeom>
+          <a:solidFill>
+            <a:srgbClr val="174994"/>
+          </a:solidFill>
+          <a:ln w="9525" cap="flat" cmpd="sng" algn="ctr">
+            <a:noFill/>
+            <a:prstDash val="solid"/>
+          </a:ln>
+        </p:spPr>
+        <p:style>
+          <a:lnRef idx="1">
+            <a:schemeClr val="accent1"/>
+          </a:lnRef>
+          <a:fillRef idx="3">
+            <a:schemeClr val="accent1"/>
+          </a:fillRef>
+          <a:effectRef idx="2">
+            <a:schemeClr val="accent1"/>
+          </a:effectRef>
+          <a:fontRef idx="minor">
+            <a:schemeClr val="lt1"/>
+          </a:fontRef>
+        </p:style>
+        <p:txBody>
+          <a:bodyPr vertOverflow="clip" horzOverflow="clip" wrap="none" rtlCol="0" anchor="ctr" anchorCtr="0">
+            <a:noAutofit/>
+          </a:bodyPr>
+          <a:lstStyle/>
+          <a:p>
+            <a:endParaRPr lang="en-US" dirty="0"/>
+          </a:p>
+        </p:txBody>
+      </p:sp>
+      <p:sp>
+        <p:nvSpPr>
+          <p:cNvPr id="13" name="Rectangle 12">
+            <a:extLst>
+              <a:ext uri="{FF2B5EF4-FFF2-40B4-BE49-F238E27FC236}">
+                <a16:creationId xmlns:a16="http://schemas.microsoft.com/office/drawing/2014/main" id="{E19BC905-D017-407A-9F5B-E372D05CC6A7}"/>
+              </a:ext>
+            </a:extLst>
+          </p:cNvPr>
+          <p:cNvSpPr/>
+          <p:nvPr/>
+        </p:nvSpPr>
+        <p:spPr>
+          <a:xfrm>
+            <a:off x="457200" y="1397000"/>
+            <a:ext cx="38100" cy="863600"/>
+          </a:xfrm>
+          <a:prstGeom prst="rect">
+            <a:avLst/>
+          </a:prstGeom>
+          <a:solidFill>
+            <a:srgbClr val="174994"/>
+          </a:solidFill>
+          <a:ln w="9525" cap="flat" cmpd="sng" algn="ctr">
+            <a:noFill/>
+            <a:prstDash val="solid"/>
+          </a:ln>
+        </p:spPr>
+        <p:style>
+          <a:lnRef idx="1">
+            <a:schemeClr val="accent1"/>
+          </a:lnRef>
+          <a:fillRef idx="3">
+            <a:schemeClr val="accent1"/>
+          </a:fillRef>
+          <a:effectRef idx="2">
+            <a:schemeClr val="accent1"/>
+          </a:effectRef>
+          <a:fontRef idx="minor">
+            <a:schemeClr val="lt1"/>
+          </a:fontRef>
+        </p:style>
+        <p:txBody>
+          <a:bodyPr vertOverflow="clip" horzOverflow="clip" rtlCol="0" anchor="t"/>
+          <a:lstStyle/>
+          <a:p>
+            <a:pPr algn="l"/>
+            <a:endParaRPr lang="en-US"/>
+          </a:p>
+        </p:txBody>
+      </p:sp>
+      <p:sp>
+        <p:nvSpPr>
+          <p:cNvPr id="14" name="Isosceles Triangle 13">
+            <a:extLst>
+              <a:ext uri="{FF2B5EF4-FFF2-40B4-BE49-F238E27FC236}">
+                <a16:creationId xmlns:a16="http://schemas.microsoft.com/office/drawing/2014/main" id="{77FA6849-3635-4F87-B8CB-3CA53A051F01}"/>
+              </a:ext>
+            </a:extLst>
+          </p:cNvPr>
+          <p:cNvSpPr/>
+          <p:nvPr/>
+        </p:nvSpPr>
+        <p:spPr>
+          <a:xfrm rot="10800000">
+            <a:off x="406400" y="2159000"/>
+            <a:ext cx="127000" cy="101600"/>
+          </a:xfrm>
+          <a:prstGeom prst="triangle">
+            <a:avLst/>
+          </a:prstGeom>
+          <a:solidFill>
+            <a:srgbClr val="174994"/>
+          </a:solidFill>
+          <a:ln w="9525" cap="flat" cmpd="sng" algn="ctr">
+            <a:noFill/>
+            <a:prstDash val="solid"/>
+          </a:ln>
+        </p:spPr>
+        <p:style>
+          <a:lnRef idx="1">
+            <a:schemeClr val="accent1"/>
+          </a:lnRef>
+          <a:fillRef idx="3">
+            <a:schemeClr val="accent1"/>
+          </a:fillRef>
+          <a:effectRef idx="2">
+            <a:schemeClr val="accent1"/>
+          </a:effectRef>
+          <a:fontRef idx="minor">
+            <a:schemeClr val="lt1"/>
+          </a:fontRef>
+        </p:style>
+        <p:txBody>
+          <a:bodyPr vertOverflow="clip" horzOverflow="clip" rtlCol="0" anchor="t"/>
+          <a:lstStyle/>
+          <a:p>
+            <a:pPr algn="l"/>
+            <a:endParaRPr lang="en-US"/>
+          </a:p>
+        </p:txBody>
+      </p:sp>
+      <p:sp>
+        <p:nvSpPr>
+          <p:cNvPr id="15" name="Rectangle 14">
+            <a:extLst>
+              <a:ext uri="{FF2B5EF4-FFF2-40B4-BE49-F238E27FC236}">
+                <a16:creationId xmlns:a16="http://schemas.microsoft.com/office/drawing/2014/main" id="{57CF6893-2268-4669-9D0F-A6D1C070D763}"/>
+              </a:ext>
+            </a:extLst>
+          </p:cNvPr>
+          <p:cNvSpPr/>
+          <p:nvPr/>
+        </p:nvSpPr>
+        <p:spPr>
+          <a:xfrm>
+            <a:off x="457200" y="2743200"/>
+            <a:ext cx="38100" cy="863600"/>
+          </a:xfrm>
+          <a:prstGeom prst="rect">
+            <a:avLst/>
+          </a:prstGeom>
+          <a:solidFill>
+            <a:srgbClr val="174994"/>
+          </a:solidFill>
+          <a:ln w="9525" cap="flat" cmpd="sng" algn="ctr">
+            <a:noFill/>
+            <a:prstDash val="solid"/>
+          </a:ln>
+        </p:spPr>
+        <p:style>
+          <a:lnRef idx="1">
+            <a:schemeClr val="accent1"/>
+          </a:lnRef>
+          <a:fillRef idx="3">
+            <a:schemeClr val="accent1"/>
+          </a:fillRef>
+          <a:effectRef idx="2">
+            <a:schemeClr val="accent1"/>
+          </a:effectRef>
+          <a:fontRef idx="minor">
+            <a:schemeClr val="lt1"/>
+          </a:fontRef>
+        </p:style>
+        <p:txBody>
+          <a:bodyPr vertOverflow="clip" horzOverflow="clip" rtlCol="0" anchor="t"/>
+          <a:lstStyle/>
+          <a:p>
+            <a:pPr algn="l"/>
+            <a:endParaRPr lang="en-US"/>
+          </a:p>
+        </p:txBody>
+      </p:sp>
+      <p:sp>
+        <p:nvSpPr>
+          <p:cNvPr id="16" name="Isosceles Triangle 15">
+            <a:extLst>
+              <a:ext uri="{FF2B5EF4-FFF2-40B4-BE49-F238E27FC236}">
+                <a16:creationId xmlns:a16="http://schemas.microsoft.com/office/drawing/2014/main" id="{A4A2E380-6FA1-40A6-922D-1580900C73A3}"/>
+              </a:ext>
+            </a:extLst>
+          </p:cNvPr>
+          <p:cNvSpPr/>
+          <p:nvPr/>
+        </p:nvSpPr>
+        <p:spPr>
+          <a:xfrm rot="10800000">
+            <a:off x="406400" y="3505200"/>
+            <a:ext cx="127000" cy="101600"/>
+          </a:xfrm>
+          <a:prstGeom prst="triangle">
+            <a:avLst/>
+          </a:prstGeom>
+          <a:solidFill>
+            <a:srgbClr val="174994"/>
+          </a:solidFill>
+          <a:ln w="9525" cap="flat" cmpd="sng" algn="ctr">
+            <a:noFill/>
+            <a:prstDash val="solid"/>
+          </a:ln>
+        </p:spPr>
+        <p:style>
+          <a:lnRef idx="1">
+            <a:schemeClr val="accent1"/>
+          </a:lnRef>
+          <a:fillRef idx="3">
+            <a:schemeClr val="accent1"/>
+          </a:fillRef>
+          <a:effectRef idx="2">
+            <a:schemeClr val="accent1"/>
+          </a:effectRef>
+          <a:fontRef idx="minor">
+            <a:schemeClr val="lt1"/>
+          </a:fontRef>
+        </p:style>
+        <p:txBody>
+          <a:bodyPr vertOverflow="clip" horzOverflow="clip" rtlCol="0" anchor="t"/>
+          <a:lstStyle/>
+          <a:p>
+            <a:pPr algn="l"/>
+            <a:endParaRPr lang="en-US"/>
+          </a:p>
+        </p:txBody>
+      </p:sp>
+      <p:sp>
+        <p:nvSpPr>
+          <p:cNvPr id="17" name="Rectangle 16">
+            <a:extLst>
+              <a:ext uri="{FF2B5EF4-FFF2-40B4-BE49-F238E27FC236}">
+                <a16:creationId xmlns:a16="http://schemas.microsoft.com/office/drawing/2014/main" id="{6F265BE2-DF71-4A9D-BE3A-B19630B60945}"/>
+              </a:ext>
+            </a:extLst>
+          </p:cNvPr>
+          <p:cNvSpPr/>
+          <p:nvPr/>
+        </p:nvSpPr>
+        <p:spPr>
+          <a:xfrm>
+            <a:off x="457200" y="4089400"/>
+            <a:ext cx="38100" cy="863600"/>
+          </a:xfrm>
+          <a:prstGeom prst="rect">
+            <a:avLst/>
+          </a:prstGeom>
+          <a:solidFill>
+            <a:srgbClr val="174994"/>
+          </a:solidFill>
+          <a:ln w="9525" cap="flat" cmpd="sng" algn="ctr">
+            <a:noFill/>
+            <a:prstDash val="solid"/>
+          </a:ln>
+        </p:spPr>
+        <p:style>
+          <a:lnRef idx="1">
+            <a:schemeClr val="accent1"/>
+          </a:lnRef>
+          <a:fillRef idx="3">
+            <a:schemeClr val="accent1"/>
+          </a:fillRef>
+          <a:effectRef idx="2">
+            <a:schemeClr val="accent1"/>
+          </a:effectRef>
+          <a:fontRef idx="minor">
+            <a:schemeClr val="lt1"/>
+          </a:fontRef>
+        </p:style>
+        <p:txBody>
+          <a:bodyPr vertOverflow="clip" horzOverflow="clip" rtlCol="0" anchor="t"/>
+          <a:lstStyle/>
+          <a:p>
+            <a:pPr algn="l"/>
+            <a:endParaRPr lang="en-US"/>
+          </a:p>
+        </p:txBody>
+      </p:sp>
+      <p:sp>
+        <p:nvSpPr>
+          <p:cNvPr id="18" name="Isosceles Triangle 17">
+            <a:extLst>
+              <a:ext uri="{FF2B5EF4-FFF2-40B4-BE49-F238E27FC236}">
+                <a16:creationId xmlns:a16="http://schemas.microsoft.com/office/drawing/2014/main" id="{D4D2BDBA-49B9-4013-9904-B5B36975CCE2}"/>
+              </a:ext>
+            </a:extLst>
+          </p:cNvPr>
+          <p:cNvSpPr/>
+          <p:nvPr/>
+        </p:nvSpPr>
+        <p:spPr>
+          <a:xfrm rot="10800000">
+            <a:off x="406400" y="4851400"/>
+            <a:ext cx="127000" cy="101600"/>
+          </a:xfrm>
+          <a:prstGeom prst="triangle">
+            <a:avLst/>
+          </a:prstGeom>
+          <a:solidFill>
+            <a:srgbClr val="174994"/>
+          </a:solidFill>
+          <a:ln w="9525" cap="flat" cmpd="sng" algn="ctr">
+            <a:noFill/>
+            <a:prstDash val="solid"/>
+          </a:ln>
+        </p:spPr>
+        <p:style>
+          <a:lnRef idx="1">
+            <a:schemeClr val="accent1"/>
+          </a:lnRef>
+          <a:fillRef idx="3">
+            <a:schemeClr val="accent1"/>
+          </a:fillRef>
+          <a:effectRef idx="2">
+            <a:schemeClr val="accent1"/>
+          </a:effectRef>
+          <a:fontRef idx="minor">
+            <a:schemeClr val="lt1"/>
+          </a:fontRef>
+        </p:style>
+        <p:txBody>
+          <a:bodyPr vertOverflow="clip" horzOverflow="clip" rtlCol="0" anchor="t"/>
+          <a:lstStyle/>
+          <a:p>
+            <a:pPr algn="l"/>
+            <a:endParaRPr lang="en-US"/>
+          </a:p>
+        </p:txBody>
+      </p:sp>
+      <p:sp>
+        <p:nvSpPr>
+          <p:cNvPr id="19" name="TextBox 18">
+            <a:extLst>
+              <a:ext uri="{FF2B5EF4-FFF2-40B4-BE49-F238E27FC236}">
+                <a16:creationId xmlns:a16="http://schemas.microsoft.com/office/drawing/2014/main" id="{0B33417F-2279-4031-8FB4-CF743A373134}"/>
               </a:ext>
             </a:extLst>
           </p:cNvPr>
@@ -4557,8 +4860,8 @@
         </p:nvSpPr>
         <p:spPr>
           <a:xfrm>
-            <a:off x="6896100" y="5791200"/>
-            <a:ext cx="4699000" cy="400110"/>
+            <a:off x="812800" y="894947"/>
+            <a:ext cx="5918200" cy="1015663"/>
           </a:xfrm>
           <a:prstGeom prst="rect">
             <a:avLst/>
@@ -4571,68 +4874,465 @@
           </a:bodyPr>
           <a:lstStyle/>
           <a:p>
-            <a:pPr algn="ctr"/>
-            <a:r>
-              <a:rPr lang="en-US" sz="1000" i="1" dirty="0">
-                <a:solidFill>
-                  <a:srgbClr val="C04040"/>
+            <a:pPr>
+              <a:buNone/>
+            </a:pPr>
+            <a:r>
+              <a:rPr lang="en-US" sz="2000" b="1" dirty="0">
+                <a:solidFill>
+                  <a:srgbClr val="174994"/>
                 </a:solidFill>
                 <a:latin typeface="Times New Roman"/>
               </a:rPr>
-              <a:t>⚠ Diagram assumes W-E limit: P</a:t>
-            </a:r>
-            <a:r>
-              <a:rPr lang="en-US" sz="1000" i="1" baseline="-25000" dirty="0">
-                <a:solidFill>
-                  <a:srgbClr val="C04040"/>
+              <a:t>Shell evolution &amp; shape coexistence</a:t>
+            </a:r>
+          </a:p>
+          <a:p>
+            <a:pPr>
+              <a:buNone/>
+            </a:pPr>
+            <a:r>
+              <a:rPr lang="en-US" sz="2000" dirty="0">
+                <a:solidFill>
+                  <a:srgbClr val="2D2D2D"/>
                 </a:solidFill>
                 <a:latin typeface="Times New Roman"/>
               </a:rPr>
-              <a:t>decay</a:t>
-            </a:r>
-            <a:r>
-              <a:rPr lang="en-US" sz="1000" i="1" dirty="0">
-                <a:solidFill>
-                  <a:srgbClr val="C04040"/>
+              <a:t>Magic numbers erode in neutron-rich nuclei; tensor </a:t>
+            </a:r>
+            <a:r>
+              <a:rPr lang="en-US" sz="2000" i="1" dirty="0">
+                <a:solidFill>
+                  <a:srgbClr val="2D2D2D"/>
                 </a:solidFill>
                 <a:latin typeface="Times New Roman"/>
               </a:rPr>
-              <a:t> independent of J</a:t>
-            </a:r>
-            <a:r>
-              <a:rPr lang="en-US" sz="1000" i="1" baseline="30000" dirty="0">
-                <a:solidFill>
-                  <a:srgbClr val="C04040"/>
+              <a:t>NN</a:t>
+            </a:r>
+            <a:r>
+              <a:rPr lang="en-US" sz="2000" dirty="0">
+                <a:solidFill>
+                  <a:srgbClr val="2D2D2D"/>
+                </a:solidFill>
+                <a:latin typeface="Times New Roman"/>
+              </a:rPr>
+              <a:t> force drives coexisting deformations</a:t>
+            </a:r>
+          </a:p>
+        </p:txBody>
+      </p:sp>
+      <p:sp>
+        <p:nvSpPr>
+          <p:cNvPr id="20" name="TextBox 19">
+            <a:extLst>
+              <a:ext uri="{FF2B5EF4-FFF2-40B4-BE49-F238E27FC236}">
+                <a16:creationId xmlns:a16="http://schemas.microsoft.com/office/drawing/2014/main" id="{10D078F6-F017-42D6-AE7B-9D6A52307F4E}"/>
+              </a:ext>
+            </a:extLst>
+          </p:cNvPr>
+          <p:cNvSpPr txBox="1"/>
+          <p:nvPr/>
+        </p:nvSpPr>
+        <p:spPr>
+          <a:xfrm>
+            <a:off x="812800" y="2241147"/>
+            <a:ext cx="5918200" cy="1015663"/>
+          </a:xfrm>
+          <a:prstGeom prst="rect">
+            <a:avLst/>
+          </a:prstGeom>
+          <a:noFill/>
+        </p:spPr>
+        <p:txBody>
+          <a:bodyPr vertOverflow="overflow" vert="horz" wrap="square" rtlCol="0" anchor="t">
+            <a:spAutoFit/>
+          </a:bodyPr>
+          <a:lstStyle/>
+          <a:p>
+            <a:pPr>
+              <a:buNone/>
+            </a:pPr>
+            <a:r>
+              <a:rPr lang="en-US" sz="2000" b="1" dirty="0">
+                <a:solidFill>
+                  <a:srgbClr val="174994"/>
+                </a:solidFill>
+                <a:latin typeface="Times New Roman"/>
+              </a:rPr>
+              <a:t>Probe via direct &amp; surrogate reactions</a:t>
+            </a:r>
+          </a:p>
+          <a:p>
+            <a:pPr>
+              <a:buNone/>
+            </a:pPr>
+            <a:r>
+              <a:rPr lang="en-US" sz="2000" dirty="0">
+                <a:solidFill>
+                  <a:srgbClr val="2D2D2D"/>
+                </a:solidFill>
+                <a:latin typeface="Times New Roman"/>
+              </a:rPr>
+              <a:t>(d,p) / (p,d) → </a:t>
+            </a:r>
+            <a:r>
+              <a:rPr lang="en-US" sz="2000" i="1" dirty="0">
+                <a:solidFill>
+                  <a:srgbClr val="2D2D2D"/>
+                </a:solidFill>
+                <a:latin typeface="Times New Roman"/>
+              </a:rPr>
+              <a:t>C</a:t>
+            </a:r>
+            <a:r>
+              <a:rPr lang="en-US" sz="2000" baseline="30000" dirty="0">
+                <a:solidFill>
+                  <a:srgbClr val="2D2D2D"/>
+                </a:solidFill>
+                <a:latin typeface="Times New Roman"/>
+              </a:rPr>
+              <a:t>2</a:t>
+            </a:r>
+            <a:r>
+              <a:rPr lang="en-US" sz="2000" i="1" dirty="0">
+                <a:solidFill>
+                  <a:srgbClr val="2D2D2D"/>
+                </a:solidFill>
+                <a:latin typeface="Times New Roman"/>
+              </a:rPr>
+              <a:t>S</a:t>
+            </a:r>
+            <a:r>
+              <a:rPr lang="en-US" sz="2000" dirty="0">
+                <a:solidFill>
+                  <a:srgbClr val="2D2D2D"/>
+                </a:solidFill>
+                <a:latin typeface="Times New Roman"/>
+              </a:rPr>
+              <a:t>, </a:t>
+            </a:r>
+            <a:r>
+              <a:rPr lang="en-US" sz="2000" i="1" dirty="0">
+                <a:solidFill>
+                  <a:srgbClr val="2D2D2D"/>
+                </a:solidFill>
+                <a:latin typeface="Times New Roman"/>
+              </a:rPr>
+              <a:t>J</a:t>
+            </a:r>
+            <a:r>
+              <a:rPr lang="en-US" sz="2000" baseline="30000" dirty="0">
+                <a:solidFill>
+                  <a:srgbClr val="2D2D2D"/>
                 </a:solidFill>
                 <a:latin typeface="Times New Roman"/>
               </a:rPr>
               <a:t>π</a:t>
             </a:r>
             <a:r>
-              <a:rPr lang="en-US" sz="1000" i="1" dirty="0">
-                <a:solidFill>
-                  <a:srgbClr val="C04040"/>
+              <a:rPr lang="en-US" sz="2000" dirty="0">
+                <a:solidFill>
+                  <a:srgbClr val="2D2D2D"/>
                 </a:solidFill>
                 <a:latin typeface="Times New Roman"/>
               </a:rPr>
-              <a:t> — surrogates populate different J</a:t>
-            </a:r>
-            <a:r>
-              <a:rPr lang="en-US" sz="1000" i="1" baseline="30000" dirty="0">
-                <a:solidFill>
-                  <a:srgbClr val="C04040"/>
+              <a:t>; surrogates constrain </a:t>
+            </a:r>
+            <a:r>
+              <a:rPr lang="en-US" sz="2000" i="1" dirty="0">
+                <a:solidFill>
+                  <a:srgbClr val="2D2D2D"/>
                 </a:solidFill>
                 <a:latin typeface="Times New Roman"/>
               </a:rPr>
-              <a:t>π</a:t>
-            </a:r>
-          </a:p>
-        </p:txBody>
-      </p:sp>
+              <a:t>r</a:t>
+            </a:r>
+            <a:r>
+              <a:rPr lang="en-US" sz="2000" dirty="0">
+                <a:solidFill>
+                  <a:srgbClr val="2D2D2D"/>
+                </a:solidFill>
+                <a:latin typeface="Times New Roman"/>
+              </a:rPr>
+              <a:t>-process (n,γ) rates</a:t>
+            </a:r>
+          </a:p>
+        </p:txBody>
+      </p:sp>
+      <p:sp>
+        <p:nvSpPr>
+          <p:cNvPr id="21" name="TextBox 20">
+            <a:extLst>
+              <a:ext uri="{FF2B5EF4-FFF2-40B4-BE49-F238E27FC236}">
+                <a16:creationId xmlns:a16="http://schemas.microsoft.com/office/drawing/2014/main" id="{5A2329D1-4B6E-4E40-BE55-1CAB04418595}"/>
+              </a:ext>
+            </a:extLst>
+          </p:cNvPr>
+          <p:cNvSpPr txBox="1"/>
+          <p:nvPr/>
+        </p:nvSpPr>
+        <p:spPr>
+          <a:xfrm>
+            <a:off x="812800" y="3587347"/>
+            <a:ext cx="5918200" cy="1015663"/>
+          </a:xfrm>
+          <a:prstGeom prst="rect">
+            <a:avLst/>
+          </a:prstGeom>
+          <a:noFill/>
+        </p:spPr>
+        <p:txBody>
+          <a:bodyPr vertOverflow="overflow" vert="horz" wrap="square" rtlCol="0" anchor="t">
+            <a:spAutoFit/>
+          </a:bodyPr>
+          <a:lstStyle/>
+          <a:p>
+            <a:pPr>
+              <a:buNone/>
+            </a:pPr>
+            <a:r>
+              <a:rPr lang="en-US" sz="2000" b="1" dirty="0">
+                <a:solidFill>
+                  <a:srgbClr val="174994"/>
+                </a:solidFill>
+                <a:latin typeface="Times New Roman"/>
+              </a:rPr>
+              <a:t>Active-target TPCs for rare-isotope beams</a:t>
+            </a:r>
+          </a:p>
+          <a:p>
+            <a:pPr>
+              <a:buNone/>
+            </a:pPr>
+            <a:r>
+              <a:rPr lang="en-US" sz="2000" dirty="0">
+                <a:solidFill>
+                  <a:srgbClr val="2D2D2D"/>
+                </a:solidFill>
+                <a:latin typeface="Times New Roman"/>
+              </a:rPr>
+              <a:t>Gas = target + detector → thick-target luminosity, full kinematics</a:t>
+            </a:r>
+          </a:p>
+        </p:txBody>
+      </p:sp>
+      <p:sp>
+        <p:nvSpPr>
+          <p:cNvPr id="22" name="TextBox 21">
+            <a:extLst>
+              <a:ext uri="{FF2B5EF4-FFF2-40B4-BE49-F238E27FC236}">
+                <a16:creationId xmlns:a16="http://schemas.microsoft.com/office/drawing/2014/main" id="{34F96D69-F251-45D6-A610-B1948F963929}"/>
+              </a:ext>
+            </a:extLst>
+          </p:cNvPr>
+          <p:cNvSpPr txBox="1"/>
+          <p:nvPr/>
+        </p:nvSpPr>
+        <p:spPr>
+          <a:xfrm>
+            <a:off x="812800" y="4933547"/>
+            <a:ext cx="5918200" cy="1015663"/>
+          </a:xfrm>
+          <a:prstGeom prst="rect">
+            <a:avLst/>
+          </a:prstGeom>
+          <a:noFill/>
+        </p:spPr>
+        <p:txBody>
+          <a:bodyPr vertOverflow="overflow" vert="horz" wrap="square" rtlCol="0" anchor="t">
+            <a:spAutoFit/>
+          </a:bodyPr>
+          <a:lstStyle/>
+          <a:p>
+            <a:pPr>
+              <a:buNone/>
+            </a:pPr>
+            <a:r>
+              <a:rPr lang="en-US" sz="2000" b="1" dirty="0">
+                <a:solidFill>
+                  <a:srgbClr val="174994"/>
+                </a:solidFill>
+                <a:latin typeface="Times New Roman"/>
+              </a:rPr>
+              <a:t>Bottleneck: particle ID in the TPC</a:t>
+            </a:r>
+          </a:p>
+          <a:p>
+            <a:pPr>
+              <a:buNone/>
+            </a:pPr>
+            <a:r>
+              <a:rPr lang="en-US" sz="2000" dirty="0">
+                <a:solidFill>
+                  <a:srgbClr val="2D2D2D"/>
+                </a:solidFill>
+                <a:latin typeface="Times New Roman"/>
+              </a:rPr>
+              <a:t>Overlapping d</a:t>
+            </a:r>
+            <a:r>
+              <a:rPr lang="en-US" sz="2000" i="1" dirty="0">
+                <a:solidFill>
+                  <a:srgbClr val="2D2D2D"/>
+                </a:solidFill>
+                <a:latin typeface="Times New Roman"/>
+              </a:rPr>
+              <a:t>E</a:t>
+            </a:r>
+            <a:r>
+              <a:rPr lang="en-US" sz="2000" dirty="0">
+                <a:solidFill>
+                  <a:srgbClr val="2D2D2D"/>
+                </a:solidFill>
+                <a:latin typeface="Times New Roman"/>
+              </a:rPr>
+              <a:t>/d</a:t>
+            </a:r>
+            <a:r>
+              <a:rPr lang="en-US" sz="2000" i="1" dirty="0">
+                <a:solidFill>
+                  <a:srgbClr val="2D2D2D"/>
+                </a:solidFill>
+                <a:latin typeface="Times New Roman"/>
+              </a:rPr>
+              <a:t>x</a:t>
+            </a:r>
+            <a:r>
+              <a:rPr lang="en-US" sz="2000" dirty="0">
+                <a:solidFill>
+                  <a:srgbClr val="2D2D2D"/>
+                </a:solidFill>
+                <a:latin typeface="Times New Roman"/>
+              </a:rPr>
+              <a:t> bands, pile-up → ML-based PID required</a:t>
+            </a:r>
+          </a:p>
+        </p:txBody>
+      </p:sp>
+      <p:pic>
+        <p:nvPicPr>
+          <p:cNvPr id="47" name="Graphic 47"/>
+          <p:cNvPicPr>
+            <a:picLocks noChangeAspect="1"/>
+          </p:cNvPicPr>
+          <p:nvPr/>
+        </p:nvPicPr>
+        <p:blipFill>
+          <a:blip>
+            <a:extLst>
+              <a:ext uri="{96DAC541-7B7A-43D3-8B79-37D633B846F1}">
+                <asvg:svgBlip xmlns:asvg="http://schemas.microsoft.com/office/drawing/2016/SVG/main" r:embed="rId4"/>
+              </a:ext>
+            </a:extLst>
+          </a:blip>
+          <a:stretch>
+            <a:fillRect/>
+          </a:stretch>
+        </p:blipFill>
+        <p:spPr>
+          <a:xfrm>
+            <a:off x="304800" y="990600"/>
+            <a:ext cx="330200" cy="330200"/>
+          </a:xfrm>
+          <a:prstGeom prst="rect">
+            <a:avLst/>
+          </a:prstGeom>
+        </p:spPr>
+      </p:pic>
+      <p:pic>
+        <p:nvPicPr>
+          <p:cNvPr id="48" name="Graphic 48"/>
+          <p:cNvPicPr>
+            <a:picLocks noChangeAspect="1"/>
+          </p:cNvPicPr>
+          <p:nvPr/>
+        </p:nvPicPr>
+        <p:blipFill>
+          <a:blip>
+            <a:extLst>
+              <a:ext uri="{96DAC541-7B7A-43D3-8B79-37D633B846F1}">
+                <asvg:svgBlip xmlns:asvg="http://schemas.microsoft.com/office/drawing/2016/SVG/main" r:embed="rId5"/>
+              </a:ext>
+            </a:extLst>
+          </a:blip>
+          <a:stretch>
+            <a:fillRect/>
+          </a:stretch>
+        </p:blipFill>
+        <p:spPr>
+          <a:xfrm>
+            <a:off x="304800" y="2336800"/>
+            <a:ext cx="330200" cy="330200"/>
+          </a:xfrm>
+          <a:prstGeom prst="rect">
+            <a:avLst/>
+          </a:prstGeom>
+        </p:spPr>
+      </p:pic>
+      <p:pic>
+        <p:nvPicPr>
+          <p:cNvPr id="49" name="Graphic 49"/>
+          <p:cNvPicPr>
+            <a:picLocks noChangeAspect="1"/>
+          </p:cNvPicPr>
+          <p:nvPr/>
+        </p:nvPicPr>
+        <p:blipFill>
+          <a:blip>
+            <a:extLst>
+              <a:ext uri="{96DAC541-7B7A-43D3-8B79-37D633B846F1}">
+                <asvg:svgBlip xmlns:asvg="http://schemas.microsoft.com/office/drawing/2016/SVG/main" r:embed="rId6"/>
+              </a:ext>
+            </a:extLst>
+          </a:blip>
+          <a:stretch>
+            <a:fillRect/>
+          </a:stretch>
+        </p:blipFill>
+        <p:spPr>
+          <a:xfrm>
+            <a:off x="304800" y="3683000"/>
+            <a:ext cx="330200" cy="330200"/>
+          </a:xfrm>
+          <a:prstGeom prst="rect">
+            <a:avLst/>
+          </a:prstGeom>
+        </p:spPr>
+      </p:pic>
+      <p:pic>
+        <p:nvPicPr>
+          <p:cNvPr id="50" name="Graphic 50"/>
+          <p:cNvPicPr>
+            <a:picLocks noChangeAspect="1"/>
+          </p:cNvPicPr>
+          <p:nvPr/>
+        </p:nvPicPr>
+        <p:blipFill>
+          <a:blip>
+            <a:extLst>
+              <a:ext uri="{96DAC541-7B7A-43D3-8B79-37D633B846F1}">
+                <asvg:svgBlip xmlns:asvg="http://schemas.microsoft.com/office/drawing/2016/SVG/main" r:embed="rId7"/>
+              </a:ext>
+            </a:extLst>
+          </a:blip>
+          <a:stretch>
+            <a:fillRect/>
+          </a:stretch>
+        </p:blipFill>
+        <p:spPr>
+          <a:xfrm>
+            <a:off x="304800" y="5029200"/>
+            <a:ext cx="330200" cy="330200"/>
+          </a:xfrm>
+          <a:prstGeom prst="rect">
+            <a:avLst/>
+          </a:prstGeom>
+        </p:spPr>
+      </p:pic>
     </p:spTree>
     <p:extLst>
       <p:ext uri="{BB962C8B-B14F-4D97-AF65-F5344CB8AC3E}">
-        <p14:creationId xmlns:p14="http://schemas.microsoft.com/office/powerpoint/2010/main" val="1497468000"/>
+        <p14:creationId xmlns:p14="http://schemas.microsoft.com/office/powerpoint/2010/main" val="3291417295"/>
       </p:ext>
     </p:extLst>
   </p:cSld>
@@ -7010,7 +7710,7 @@
 
 <file path=ppt/webextensions/taskpanes.xml><?xml version="1.0" encoding="utf-8"?>
 <wetp:taskpanes xmlns:wetp="http://schemas.microsoft.com/office/webextensions/taskpanes/2010/11">
-  <wetp:taskpane dockstate="right" visibility="0" width="482" row="9">
+  <wetp:taskpane dockstate="right" visibility="0" width="662" row="9">
     <wetp:webextensionref xmlns:r="http://schemas.openxmlformats.org/officeDocument/2006/relationships" r:id="rId1"/>
   </wetp:taskpane>
 </wetp:taskpanes>

</xml_diff>

<commit_message>
vault backup: 2026-04-12 20:44:42
</commit_message>
<xml_diff>
--- a/99_System/.scratch/imai-presentation/Imai_Meeting_20260413.pptx
+++ b/99_System/.scratch/imai-presentation/Imai_Meeting_20260413.pptx
@@ -2,14 +2,14 @@
 <file path=ppt/presentation.xml><?xml version="1.0" encoding="utf-8"?>
 <p:presentation xmlns:a="http://schemas.openxmlformats.org/drawingml/2006/main" xmlns:r="http://schemas.openxmlformats.org/officeDocument/2006/relationships" xmlns:p="http://schemas.openxmlformats.org/presentationml/2006/main" saveSubsetFonts="1" autoCompressPictures="0">
   <p:sldMasterIdLst>
-    <p:sldMasterId id="2147483648" r:id="rId1"/>
+    <p:sldMasterId id="2147483672" r:id="rId1"/>
   </p:sldMasterIdLst>
   <p:notesMasterIdLst>
     <p:notesMasterId r:id="rId7"/>
   </p:notesMasterIdLst>
   <p:sldIdLst>
-    <p:sldId id="287" r:id="rId2"/>
-    <p:sldId id="262" r:id="rId3"/>
+    <p:sldId id="298" r:id="rId2"/>
+    <p:sldId id="299" r:id="rId3"/>
     <p:sldId id="263" r:id="rId4"/>
     <p:sldId id="264" r:id="rId5"/>
     <p:sldId id="265" r:id="rId6"/>
@@ -300,67 +300,70 @@
           <a:lstStyle/>
           <a:p>
             <a:r>
-              <a:rPr dirty="0"/>
-              <a:t>TALKING POINTS:</a:t>
-            </a:r>
-          </a:p>
-          <a:p>
-            <a:r>
-              <a:rPr dirty="0"/>
-              <a:t>- Shell evolution is the fundamental question: how does nuclear structure change as we add neutrons far from stability?</a:t>
-            </a:r>
-          </a:p>
-          <a:p>
-            <a:r>
-              <a:rPr dirty="0"/>
-              <a:t>- Magic numbers we learned (2,8,20,28,50,82,126) aren't universal -- tensor force monopole reshuffles levels (Otsuka et al., RMP 2020).</a:t>
-            </a:r>
-          </a:p>
-          <a:p>
-            <a:r>
-              <a:rPr dirty="0"/>
-              <a:t>- Direct reactions are the tool: single-step, ~10^-22 s, probe nuclear surface. DWBA analysis extracts C2S.</a:t>
-            </a:r>
-          </a:p>
-          <a:p>
-            <a:r>
-              <a:rPr dirty="0"/>
-              <a:t>- Active-target TPCs solve the luminosity problem for exotic beam experiments at facilities like HIRFL-RIBLL (IMP) and RIKEN RIBF.</a:t>
-            </a:r>
-          </a:p>
-          <a:p>
-            <a:r>
-              <a:rPr dirty="0"/>
-              <a:t>- But the killer problem is PID: you need clean channel identification to gate on the correct reaction. Classical </a:t>
-            </a:r>
-            <a:r>
-              <a:rPr dirty="0" err="1"/>
-              <a:t>dE</a:t>
-            </a:r>
-            <a:r>
-              <a:rPr dirty="0"/>
-              <a:t>-E cuts struggle with overlapping Bethe-Bloch curves, especially for similar A/Z species.</a:t>
-            </a:r>
-          </a:p>
-          <a:p>
-            <a:r>
-              <a:rPr dirty="0"/>
-              <a:t>- This motivates our ML approach.</a:t>
-            </a:r>
-          </a:p>
-          <a:p>
-            <a:endParaRPr dirty="0"/>
-          </a:p>
-          <a:p>
-            <a:r>
-              <a:rPr dirty="0"/>
-              <a:t>FIGURE: MATE-TPC schematic from NST paper (pad plane + GEM + field cage).</a:t>
-            </a:r>
-          </a:p>
-          <a:p>
-            <a:r>
-              <a:rPr dirty="0"/>
-              <a:t>Figure path: D:\obsidian\OrbitOS\50_Resources\Physics\literature\MLforPhysics\NST-ML-12C12C-MATE\_page_3_Figure_9.jpeg</a:t>
+              <a:rPr lang="en-US" dirty="0"/>
+              <a:t>Let me start by framing the physics motivation behind this work.</a:t>
+            </a:r>
+          </a:p>
+          <a:p>
+            <a:r>
+              <a:rPr lang="en-US" dirty="0"/>
+              <a:t>One of the most exciting frontiers in nuclear structure is the evolution of shell structure far from stability. We know that the traditional magic numbers can erode in neutron-rich nuclei, and the tensor component of the nucleon-nucleon force drives the coexistence of different nuclear shapes. Understanding this is a central question in modern nuclear physics.</a:t>
+            </a:r>
+          </a:p>
+          <a:p>
+            <a:r>
+              <a:rPr lang="en-US" dirty="0"/>
+              <a:t>How do we probe this experimentally? Through direct reactions like (</a:t>
+            </a:r>
+            <a:r>
+              <a:rPr lang="en-US" dirty="0" err="1"/>
+              <a:t>d,p</a:t>
+            </a:r>
+            <a:r>
+              <a:rPr lang="en-US" dirty="0"/>
+              <a:t>) and (</a:t>
+            </a:r>
+            <a:r>
+              <a:rPr lang="en-US" dirty="0" err="1"/>
+              <a:t>p,d</a:t>
+            </a:r>
+            <a:r>
+              <a:rPr lang="en-US" dirty="0"/>
+              <a:t>) transfer, which give us spectroscopic factors and spin-parity assignments. And through surrogate reactions, which allow us to indirectly constrain neutron-capture cross sections critical for r-process nucleosynthesis — reactions we simply cannot measure directly with short-lived isotopes.</a:t>
+            </a:r>
+          </a:p>
+          <a:p>
+            <a:r>
+              <a:rPr lang="en-US" dirty="0"/>
+              <a:t>The diagram on the right illustrates the surrogate reaction method: the desired cross section sigma of </a:t>
+            </a:r>
+            <a:r>
+              <a:rPr lang="en-US" dirty="0" err="1"/>
+              <a:t>n,x</a:t>
+            </a:r>
+            <a:r>
+              <a:rPr lang="en-US" dirty="0"/>
+              <a:t> is decomposed into a compound-nucleus formation cross section times a decay probability, summed over all spin-parity values. </a:t>
+            </a:r>
+            <a:r>
+              <a:rPr lang="en-US"/>
+              <a:t>This formalism is </a:t>
+            </a:r>
+            <a:r>
+              <a:rPr lang="en-US" dirty="0"/>
+              <a:t>the theoretical foundation for the surrogate approach.</a:t>
+            </a:r>
+          </a:p>
+          <a:p>
+            <a:r>
+              <a:rPr lang="en-US" dirty="0"/>
+              <a:t>Now, to carry out these measurements on rare-isotope beams, active-target time projection chambers — or TPCs — have become the instrument of choice. The gas volume serves simultaneously as the target and the detector, giving us thick-target luminosity with full kinematic coverage.</a:t>
+            </a:r>
+          </a:p>
+          <a:p>
+            <a:r>
+              <a:rPr lang="en-US" dirty="0"/>
+              <a:t>But here is the bottleneck: each experiment generates several terabytes of raw data. How to efficiently extract useful physics information from this massive volume becomes a key challenge, and this is what motivates our work.</a:t>
             </a:r>
           </a:p>
         </p:txBody>
@@ -931,7 +934,7 @@
 </file>
 
 <file path=ppt/slideLayouts/slideLayout1.xml><?xml version="1.0" encoding="utf-8"?>
-<p:sldLayout xmlns:a="http://schemas.openxmlformats.org/drawingml/2006/main" xmlns:r="http://schemas.openxmlformats.org/officeDocument/2006/relationships" xmlns:p="http://schemas.openxmlformats.org/presentationml/2006/main" type="title" preserve="1">
+<p:sldLayout xmlns:a="http://schemas.openxmlformats.org/drawingml/2006/main" xmlns:r="http://schemas.openxmlformats.org/officeDocument/2006/relationships" xmlns:p="http://schemas.openxmlformats.org/presentationml/2006/main" type="title">
   <p:cSld name="Title Slide">
     <p:spTree>
       <p:nvGrpSpPr>
@@ -1171,7 +1174,7 @@
 </file>
 
 <file path=ppt/slideLayouts/slideLayout10.xml><?xml version="1.0" encoding="utf-8"?>
-<p:sldLayout xmlns:a="http://schemas.openxmlformats.org/drawingml/2006/main" xmlns:r="http://schemas.openxmlformats.org/officeDocument/2006/relationships" xmlns:p="http://schemas.openxmlformats.org/presentationml/2006/main" type="vertTx" preserve="1">
+<p:sldLayout xmlns:a="http://schemas.openxmlformats.org/drawingml/2006/main" xmlns:r="http://schemas.openxmlformats.org/officeDocument/2006/relationships" xmlns:p="http://schemas.openxmlformats.org/presentationml/2006/main" type="vertTx">
   <p:cSld name="Title and Vertical Text">
     <p:spTree>
       <p:nvGrpSpPr>
@@ -1339,7 +1342,7 @@
 </file>
 
 <file path=ppt/slideLayouts/slideLayout11.xml><?xml version="1.0" encoding="utf-8"?>
-<p:sldLayout xmlns:a="http://schemas.openxmlformats.org/drawingml/2006/main" xmlns:r="http://schemas.openxmlformats.org/officeDocument/2006/relationships" xmlns:p="http://schemas.openxmlformats.org/presentationml/2006/main" type="vertTitleAndTx" preserve="1">
+<p:sldLayout xmlns:a="http://schemas.openxmlformats.org/drawingml/2006/main" xmlns:r="http://schemas.openxmlformats.org/officeDocument/2006/relationships" xmlns:p="http://schemas.openxmlformats.org/presentationml/2006/main" type="vertTitleAndTx">
   <p:cSld name="Vertical Title and Text">
     <p:spTree>
       <p:nvGrpSpPr>
@@ -1517,7 +1520,7 @@
 </file>
 
 <file path=ppt/slideLayouts/slideLayout2.xml><?xml version="1.0" encoding="utf-8"?>
-<p:sldLayout xmlns:a="http://schemas.openxmlformats.org/drawingml/2006/main" xmlns:r="http://schemas.openxmlformats.org/officeDocument/2006/relationships" xmlns:p="http://schemas.openxmlformats.org/presentationml/2006/main" type="obj" preserve="1">
+<p:sldLayout xmlns:a="http://schemas.openxmlformats.org/drawingml/2006/main" xmlns:r="http://schemas.openxmlformats.org/officeDocument/2006/relationships" xmlns:p="http://schemas.openxmlformats.org/presentationml/2006/main" type="obj">
   <p:cSld name="Title and Content">
     <p:spTree>
       <p:nvGrpSpPr>
@@ -1685,7 +1688,7 @@
 </file>
 
 <file path=ppt/slideLayouts/slideLayout3.xml><?xml version="1.0" encoding="utf-8"?>
-<p:sldLayout xmlns:a="http://schemas.openxmlformats.org/drawingml/2006/main" xmlns:r="http://schemas.openxmlformats.org/officeDocument/2006/relationships" xmlns:p="http://schemas.openxmlformats.org/presentationml/2006/main" type="secHead" preserve="1">
+<p:sldLayout xmlns:a="http://schemas.openxmlformats.org/drawingml/2006/main" xmlns:r="http://schemas.openxmlformats.org/officeDocument/2006/relationships" xmlns:p="http://schemas.openxmlformats.org/presentationml/2006/main" type="secHead">
   <p:cSld name="Section Header">
     <p:spTree>
       <p:nvGrpSpPr>
@@ -1930,7 +1933,7 @@
 </file>
 
 <file path=ppt/slideLayouts/slideLayout4.xml><?xml version="1.0" encoding="utf-8"?>
-<p:sldLayout xmlns:a="http://schemas.openxmlformats.org/drawingml/2006/main" xmlns:r="http://schemas.openxmlformats.org/officeDocument/2006/relationships" xmlns:p="http://schemas.openxmlformats.org/presentationml/2006/main" type="twoObj" preserve="1">
+<p:sldLayout xmlns:a="http://schemas.openxmlformats.org/drawingml/2006/main" xmlns:r="http://schemas.openxmlformats.org/officeDocument/2006/relationships" xmlns:p="http://schemas.openxmlformats.org/presentationml/2006/main" type="twoObj">
   <p:cSld name="Two Content">
     <p:spTree>
       <p:nvGrpSpPr>
@@ -2215,7 +2218,7 @@
 </file>
 
 <file path=ppt/slideLayouts/slideLayout5.xml><?xml version="1.0" encoding="utf-8"?>
-<p:sldLayout xmlns:a="http://schemas.openxmlformats.org/drawingml/2006/main" xmlns:r="http://schemas.openxmlformats.org/officeDocument/2006/relationships" xmlns:p="http://schemas.openxmlformats.org/presentationml/2006/main" type="twoTxTwoObj" preserve="1">
+<p:sldLayout xmlns:a="http://schemas.openxmlformats.org/drawingml/2006/main" xmlns:r="http://schemas.openxmlformats.org/officeDocument/2006/relationships" xmlns:p="http://schemas.openxmlformats.org/presentationml/2006/main" type="twoTxTwoObj">
   <p:cSld name="Comparison">
     <p:spTree>
       <p:nvGrpSpPr>
@@ -2634,7 +2637,7 @@
 </file>
 
 <file path=ppt/slideLayouts/slideLayout6.xml><?xml version="1.0" encoding="utf-8"?>
-<p:sldLayout xmlns:a="http://schemas.openxmlformats.org/drawingml/2006/main" xmlns:r="http://schemas.openxmlformats.org/officeDocument/2006/relationships" xmlns:p="http://schemas.openxmlformats.org/presentationml/2006/main" type="titleOnly" preserve="1">
+<p:sldLayout xmlns:a="http://schemas.openxmlformats.org/drawingml/2006/main" xmlns:r="http://schemas.openxmlformats.org/officeDocument/2006/relationships" xmlns:p="http://schemas.openxmlformats.org/presentationml/2006/main" type="titleOnly">
   <p:cSld name="Title Only">
     <p:spTree>
       <p:nvGrpSpPr>
@@ -2751,7 +2754,7 @@
 </file>
 
 <file path=ppt/slideLayouts/slideLayout7.xml><?xml version="1.0" encoding="utf-8"?>
-<p:sldLayout xmlns:a="http://schemas.openxmlformats.org/drawingml/2006/main" xmlns:r="http://schemas.openxmlformats.org/officeDocument/2006/relationships" xmlns:p="http://schemas.openxmlformats.org/presentationml/2006/main" type="blank" preserve="1">
+<p:sldLayout xmlns:a="http://schemas.openxmlformats.org/drawingml/2006/main" xmlns:r="http://schemas.openxmlformats.org/officeDocument/2006/relationships" xmlns:p="http://schemas.openxmlformats.org/presentationml/2006/main" type="blank">
   <p:cSld name="Blank">
     <p:spTree>
       <p:nvGrpSpPr>
@@ -2846,7 +2849,7 @@
 </file>
 
 <file path=ppt/slideLayouts/slideLayout8.xml><?xml version="1.0" encoding="utf-8"?>
-<p:sldLayout xmlns:a="http://schemas.openxmlformats.org/drawingml/2006/main" xmlns:r="http://schemas.openxmlformats.org/officeDocument/2006/relationships" xmlns:p="http://schemas.openxmlformats.org/presentationml/2006/main" type="objTx" preserve="1">
+<p:sldLayout xmlns:a="http://schemas.openxmlformats.org/drawingml/2006/main" xmlns:r="http://schemas.openxmlformats.org/officeDocument/2006/relationships" xmlns:p="http://schemas.openxmlformats.org/presentationml/2006/main" type="objTx">
   <p:cSld name="Content with Caption">
     <p:spTree>
       <p:nvGrpSpPr>
@@ -3121,7 +3124,7 @@
 </file>
 
 <file path=ppt/slideLayouts/slideLayout9.xml><?xml version="1.0" encoding="utf-8"?>
-<p:sldLayout xmlns:a="http://schemas.openxmlformats.org/drawingml/2006/main" xmlns:r="http://schemas.openxmlformats.org/officeDocument/2006/relationships" xmlns:p="http://schemas.openxmlformats.org/presentationml/2006/main" type="picTx" preserve="1">
+<p:sldLayout xmlns:a="http://schemas.openxmlformats.org/drawingml/2006/main" xmlns:r="http://schemas.openxmlformats.org/officeDocument/2006/relationships" xmlns:p="http://schemas.openxmlformats.org/presentationml/2006/main" type="picTx">
   <p:cSld name="Picture with Caption">
     <p:spTree>
       <p:nvGrpSpPr>
@@ -3615,17 +3618,17 @@
   </p:cSld>
   <p:clrMap bg1="lt1" tx1="dk1" bg2="lt2" tx2="dk2" accent1="accent1" accent2="accent2" accent3="accent3" accent4="accent4" accent5="accent5" accent6="accent6" hlink="hlink" folHlink="folHlink"/>
   <p:sldLayoutIdLst>
-    <p:sldLayoutId id="2147483649" r:id="rId1"/>
-    <p:sldLayoutId id="2147483650" r:id="rId2"/>
-    <p:sldLayoutId id="2147483651" r:id="rId3"/>
-    <p:sldLayoutId id="2147483652" r:id="rId4"/>
-    <p:sldLayoutId id="2147483653" r:id="rId5"/>
-    <p:sldLayoutId id="2147483654" r:id="rId6"/>
-    <p:sldLayoutId id="2147483655" r:id="rId7"/>
-    <p:sldLayoutId id="2147483656" r:id="rId8"/>
-    <p:sldLayoutId id="2147483657" r:id="rId9"/>
-    <p:sldLayoutId id="2147483658" r:id="rId10"/>
-    <p:sldLayoutId id="2147483659" r:id="rId11"/>
+    <p:sldLayoutId id="2147483673" r:id="rId1"/>
+    <p:sldLayoutId id="2147483674" r:id="rId2"/>
+    <p:sldLayoutId id="2147483675" r:id="rId3"/>
+    <p:sldLayoutId id="2147483676" r:id="rId4"/>
+    <p:sldLayoutId id="2147483677" r:id="rId5"/>
+    <p:sldLayoutId id="2147483678" r:id="rId6"/>
+    <p:sldLayoutId id="2147483679" r:id="rId7"/>
+    <p:sldLayoutId id="2147483680" r:id="rId8"/>
+    <p:sldLayoutId id="2147483681" r:id="rId9"/>
+    <p:sldLayoutId id="2147483682" r:id="rId10"/>
+    <p:sldLayoutId id="2147483683" r:id="rId11"/>
   </p:sldLayoutIdLst>
   <p:txStyles>
     <p:titleStyle>
@@ -3980,87 +3983,6 @@
       </p:sp>
       <p:sp>
         <p:nvSpPr>
-          <p:cNvPr id="4" name="Rectangle 3"/>
-          <p:cNvSpPr/>
-          <p:nvPr/>
-        </p:nvSpPr>
-        <p:spPr>
-          <a:xfrm>
-            <a:off x="457200" y="6263640"/>
-            <a:ext cx="11277295" cy="25400"/>
-          </a:xfrm>
-          <a:prstGeom prst="rect">
-            <a:avLst/>
-          </a:prstGeom>
-          <a:solidFill>
-            <a:srgbClr val="174994"/>
-          </a:solidFill>
-          <a:ln>
-            <a:noFill/>
-          </a:ln>
-        </p:spPr>
-        <p:style>
-          <a:lnRef idx="1">
-            <a:schemeClr val="accent1"/>
-          </a:lnRef>
-          <a:fillRef idx="3">
-            <a:schemeClr val="accent1"/>
-          </a:fillRef>
-          <a:effectRef idx="2">
-            <a:schemeClr val="accent1"/>
-          </a:effectRef>
-          <a:fontRef idx="minor">
-            <a:schemeClr val="lt1"/>
-          </a:fontRef>
-        </p:style>
-        <p:txBody>
-          <a:bodyPr rtlCol="0" anchor="ctr"/>
-          <a:lstStyle/>
-          <a:p>
-            <a:pPr algn="ctr"/>
-            <a:endParaRPr/>
-          </a:p>
-        </p:txBody>
-      </p:sp>
-      <p:sp>
-        <p:nvSpPr>
-          <p:cNvPr id="5" name="TextBox 4"/>
-          <p:cNvSpPr txBox="1"/>
-          <p:nvPr/>
-        </p:nvSpPr>
-        <p:spPr>
-          <a:xfrm>
-            <a:off x="11505152" y="6400800"/>
-            <a:ext cx="503663" cy="307777"/>
-          </a:xfrm>
-          <a:prstGeom prst="rect">
-            <a:avLst/>
-          </a:prstGeom>
-          <a:noFill/>
-        </p:spPr>
-        <p:txBody>
-          <a:bodyPr wrap="none">
-            <a:spAutoFit/>
-          </a:bodyPr>
-          <a:lstStyle/>
-          <a:p>
-            <a:pPr algn="r">
-              <a:defRPr sz="1400">
-                <a:solidFill>
-                  <a:srgbClr val="4A4A4A"/>
-                </a:solidFill>
-                <a:latin typeface="Times New Roman"/>
-              </a:defRPr>
-            </a:pPr>
-            <a:r>
-              <a:rPr lang="en-US" dirty="0"/>
-              <a:t>1 / 5</a:t>
-            </a:r>
-          </a:p>
-        </p:txBody>
-      </p:sp>
-      <p:sp>
-        <p:nvSpPr>
           <p:cNvPr id="30" name="DiagramTitle"/>
           <p:cNvSpPr txBox="1"/>
           <p:nvPr/>
@@ -5039,18 +4961,18 @@
               <a:t>; surrogates constrain </a:t>
             </a:r>
             <a:r>
-              <a:rPr lang="en-US" sz="2000" i="1" dirty="0">
-                <a:solidFill>
-                  <a:srgbClr val="2D2D2D"/>
+              <a:rPr lang="en-US" sz="2000" b="1" i="1" dirty="0">
+                <a:solidFill>
+                  <a:srgbClr val="CC0000"/>
                 </a:solidFill>
                 <a:latin typeface="Times New Roman"/>
               </a:rPr>
               <a:t>r</a:t>
             </a:r>
             <a:r>
-              <a:rPr lang="en-US" sz="2000" dirty="0">
-                <a:solidFill>
-                  <a:srgbClr val="2D2D2D"/>
+              <a:rPr lang="en-US" sz="2000" b="1" dirty="0">
+                <a:solidFill>
+                  <a:srgbClr val="CC0000"/>
                 </a:solidFill>
                 <a:latin typeface="Times New Roman"/>
               </a:rPr>
@@ -5154,7 +5076,25 @@
                 </a:solidFill>
                 <a:latin typeface="Times New Roman"/>
               </a:rPr>
-              <a:t>Bottleneck: particle ID in the TPC</a:t>
+              <a:t>Bottleneck: </a:t>
+            </a:r>
+            <a:r>
+              <a:rPr lang="en-US" sz="2000" b="1" dirty="0">
+                <a:solidFill>
+                  <a:srgbClr val="CC0000"/>
+                </a:solidFill>
+                <a:latin typeface="Times New Roman"/>
+              </a:rPr>
+              <a:t>TB-scale data</a:t>
+            </a:r>
+            <a:r>
+              <a:rPr lang="en-US" sz="2000" b="1" dirty="0">
+                <a:solidFill>
+                  <a:srgbClr val="174994"/>
+                </a:solidFill>
+                <a:latin typeface="Times New Roman"/>
+              </a:rPr>
+              <a:t> per experiment</a:t>
             </a:r>
           </a:p>
           <a:p>
@@ -5168,43 +5108,7 @@
                 </a:solidFill>
                 <a:latin typeface="Times New Roman"/>
               </a:rPr>
-              <a:t>Overlapping d</a:t>
-            </a:r>
-            <a:r>
-              <a:rPr lang="en-US" sz="2000" i="1" dirty="0">
-                <a:solidFill>
-                  <a:srgbClr val="2D2D2D"/>
-                </a:solidFill>
-                <a:latin typeface="Times New Roman"/>
-              </a:rPr>
-              <a:t>E</a:t>
-            </a:r>
-            <a:r>
-              <a:rPr lang="en-US" sz="2000" dirty="0">
-                <a:solidFill>
-                  <a:srgbClr val="2D2D2D"/>
-                </a:solidFill>
-                <a:latin typeface="Times New Roman"/>
-              </a:rPr>
-              <a:t>/d</a:t>
-            </a:r>
-            <a:r>
-              <a:rPr lang="en-US" sz="2000" i="1" dirty="0">
-                <a:solidFill>
-                  <a:srgbClr val="2D2D2D"/>
-                </a:solidFill>
-                <a:latin typeface="Times New Roman"/>
-              </a:rPr>
-              <a:t>x</a:t>
-            </a:r>
-            <a:r>
-              <a:rPr lang="en-US" sz="2000" dirty="0">
-                <a:solidFill>
-                  <a:srgbClr val="2D2D2D"/>
-                </a:solidFill>
-                <a:latin typeface="Times New Roman"/>
-              </a:rPr>
-              <a:t> bands, pile-up → ML-based PID required</a:t>
+              <a:t>Each run produces several TB of raw data → extracting physics from this volume is a key challenge</a:t>
             </a:r>
           </a:p>
         </p:txBody>
@@ -5329,10 +5233,91 @@
           </a:prstGeom>
         </p:spPr>
       </p:pic>
+      <p:sp>
+        <p:nvSpPr>
+          <p:cNvPr id="4" name="Rectangle 3"/>
+          <p:cNvSpPr/>
+          <p:nvPr/>
+        </p:nvSpPr>
+        <p:spPr>
+          <a:xfrm>
+            <a:off x="457200" y="6263640"/>
+            <a:ext cx="11277295" cy="25400"/>
+          </a:xfrm>
+          <a:prstGeom prst="rect">
+            <a:avLst/>
+          </a:prstGeom>
+          <a:solidFill>
+            <a:srgbClr val="174994"/>
+          </a:solidFill>
+          <a:ln>
+            <a:noFill/>
+          </a:ln>
+        </p:spPr>
+        <p:style>
+          <a:lnRef idx="1">
+            <a:schemeClr val="accent1"/>
+          </a:lnRef>
+          <a:fillRef idx="3">
+            <a:schemeClr val="accent1"/>
+          </a:fillRef>
+          <a:effectRef idx="2">
+            <a:schemeClr val="accent1"/>
+          </a:effectRef>
+          <a:fontRef idx="minor">
+            <a:schemeClr val="lt1"/>
+          </a:fontRef>
+        </p:style>
+        <p:txBody>
+          <a:bodyPr rtlCol="0" anchor="ctr"/>
+          <a:lstStyle/>
+          <a:p>
+            <a:pPr algn="ctr"/>
+            <a:endParaRPr/>
+          </a:p>
+        </p:txBody>
+      </p:sp>
+      <p:sp>
+        <p:nvSpPr>
+          <p:cNvPr id="5" name="TextBox 4"/>
+          <p:cNvSpPr txBox="1"/>
+          <p:nvPr/>
+        </p:nvSpPr>
+        <p:spPr>
+          <a:xfrm>
+            <a:off x="11505152" y="6400800"/>
+            <a:ext cx="503663" cy="307777"/>
+          </a:xfrm>
+          <a:prstGeom prst="rect">
+            <a:avLst/>
+          </a:prstGeom>
+          <a:noFill/>
+        </p:spPr>
+        <p:txBody>
+          <a:bodyPr wrap="none">
+            <a:spAutoFit/>
+          </a:bodyPr>
+          <a:lstStyle/>
+          <a:p>
+            <a:pPr algn="r">
+              <a:defRPr sz="1400">
+                <a:solidFill>
+                  <a:srgbClr val="4A4A4A"/>
+                </a:solidFill>
+                <a:latin typeface="Times New Roman"/>
+              </a:defRPr>
+            </a:pPr>
+            <a:r>
+              <a:rPr lang="en-US" dirty="0"/>
+              <a:t>1 / 5</a:t>
+            </a:r>
+          </a:p>
+        </p:txBody>
+      </p:sp>
     </p:spTree>
     <p:extLst>
       <p:ext uri="{BB962C8B-B14F-4D97-AF65-F5344CB8AC3E}">
-        <p14:creationId xmlns:p14="http://schemas.microsoft.com/office/powerpoint/2010/main" val="3291417295"/>
+        <p14:creationId xmlns:p14="http://schemas.microsoft.com/office/powerpoint/2010/main" val="3031773127"/>
       </p:ext>
     </p:extLst>
   </p:cSld>
@@ -5442,6 +5427,216 @@
       </p:sp>
       <p:sp>
         <p:nvSpPr>
+          <p:cNvPr id="6" name="TextBox 5"/>
+          <p:cNvSpPr txBox="1"/>
+          <p:nvPr/>
+        </p:nvSpPr>
+        <p:spPr>
+          <a:xfrm>
+            <a:off x="640080" y="800100"/>
+            <a:ext cx="10599848" cy="4247317"/>
+          </a:xfrm>
+          <a:prstGeom prst="rect">
+            <a:avLst/>
+          </a:prstGeom>
+          <a:noFill/>
+        </p:spPr>
+        <p:txBody>
+          <a:bodyPr wrap="square">
+            <a:spAutoFit/>
+          </a:bodyPr>
+          <a:lstStyle/>
+          <a:p>
+            <a:pPr>
+              <a:spcAft>
+                <a:spcPts val="600"/>
+              </a:spcAft>
+              <a:defRPr sz="1600" b="1">
+                <a:solidFill>
+                  <a:srgbClr val="174994"/>
+                </a:solidFill>
+                <a:latin typeface="Times New Roman"/>
+              </a:defRPr>
+            </a:pPr>
+            <a:r>
+              <a:rPr lang="en-US" sz="2000" dirty="0"/>
+              <a:t>Traditional methods struggle with TPC data</a:t>
+            </a:r>
+          </a:p>
+          <a:p>
+            <a:pPr lvl="1">
+              <a:spcAft>
+                <a:spcPts val="600"/>
+              </a:spcAft>
+              <a:defRPr sz="1600">
+                <a:solidFill>
+                  <a:srgbClr val="2D2D2D"/>
+                </a:solidFill>
+                <a:latin typeface="Times New Roman"/>
+              </a:defRPr>
+            </a:pPr>
+            <a:r>
+              <a:rPr lang="en-US" sz="2000" dirty="0"/>
+              <a:t>dE-E: overlapping distributions at similar A/Z (e.g., ³He/⁴He, ¹³C/¹⁴C)</a:t>
+            </a:r>
+          </a:p>
+          <a:p>
+            <a:pPr lvl="1">
+              <a:spcAft>
+                <a:spcPts val="600"/>
+              </a:spcAft>
+              <a:defRPr sz="1600">
+                <a:solidFill>
+                  <a:srgbClr val="2D2D2D"/>
+                </a:solidFill>
+                <a:latin typeface="Times New Roman"/>
+              </a:defRPr>
+            </a:pPr>
+            <a:r>
+              <a:rPr lang="en-US" sz="2000" dirty="0"/>
+              <a:t>Bragg-curve fitting: pile-up, dynamic range across beam vs. recoil region</a:t>
+            </a:r>
+          </a:p>
+          <a:p>
+            <a:pPr lvl="1">
+              <a:spcAft>
+                <a:spcPts val="600"/>
+              </a:spcAft>
+              <a:defRPr sz="1600">
+                <a:solidFill>
+                  <a:srgbClr val="2D2D2D"/>
+                </a:solidFill>
+                <a:latin typeface="Times New Roman"/>
+              </a:defRPr>
+            </a:pPr>
+            <a:r>
+              <a:rPr lang="en-US" sz="2000" dirty="0"/>
+              <a:t>Hough transform mislabels ~1.5% of events (NST-2025-0958)</a:t>
+            </a:r>
+          </a:p>
+          <a:p>
+            <a:pPr>
+              <a:spcAft>
+                <a:spcPts val="600"/>
+              </a:spcAft>
+              <a:defRPr sz="1600" b="1">
+                <a:solidFill>
+                  <a:srgbClr val="174994"/>
+                </a:solidFill>
+                <a:latin typeface="Times New Roman"/>
+              </a:defRPr>
+            </a:pPr>
+            <a:r>
+              <a:rPr lang="en-US" sz="2000" dirty="0"/>
+              <a:t>MATE-TPC at IMP (HIRFL-RIBLL)</a:t>
+            </a:r>
+          </a:p>
+          <a:p>
+            <a:pPr lvl="1">
+              <a:spcAft>
+                <a:spcPts val="600"/>
+              </a:spcAft>
+              <a:defRPr sz="1600">
+                <a:solidFill>
+                  <a:srgbClr val="2D2D2D"/>
+                </a:solidFill>
+                <a:latin typeface="Times New Roman"/>
+              </a:defRPr>
+            </a:pPr>
+            <a:r>
+              <a:rPr lang="en-US" sz="2000" dirty="0"/>
+              <a:t>GEM readout, 3,792 triangular pads (48×80), GET electronics</a:t>
+            </a:r>
+          </a:p>
+          <a:p>
+            <a:pPr lvl="1">
+              <a:spcAft>
+                <a:spcPts val="600"/>
+              </a:spcAft>
+              <a:defRPr sz="1600">
+                <a:solidFill>
+                  <a:srgbClr val="2D2D2D"/>
+                </a:solidFill>
+                <a:latin typeface="Times New Roman"/>
+              </a:defRPr>
+            </a:pPr>
+            <a:r>
+              <a:rPr lang="en-US" sz="2000" dirty="0"/>
+              <a:t>¹²C+¹²C commissioning data: elastic vs. fusion + 5 reaction channels</a:t>
+            </a:r>
+          </a:p>
+          <a:p>
+            <a:pPr>
+              <a:spcAft>
+                <a:spcPts val="600"/>
+              </a:spcAft>
+              <a:defRPr sz="1600" b="1">
+                <a:solidFill>
+                  <a:srgbClr val="174994"/>
+                </a:solidFill>
+                <a:latin typeface="Times New Roman"/>
+              </a:defRPr>
+            </a:pPr>
+            <a:r>
+              <a:rPr lang="en-US" sz="2000" dirty="0"/>
+              <a:t>Key insight: 2D track images encode species-specific spatial signatures</a:t>
+            </a:r>
+          </a:p>
+          <a:p>
+            <a:pPr lvl="1">
+              <a:spcAft>
+                <a:spcPts val="600"/>
+              </a:spcAft>
+              <a:defRPr sz="1600">
+                <a:solidFill>
+                  <a:srgbClr val="2D2D2D"/>
+                </a:solidFill>
+                <a:latin typeface="Times New Roman"/>
+              </a:defRPr>
+            </a:pPr>
+            <a:r>
+              <a:rPr lang="en-US" sz="2000" dirty="0"/>
+              <a:t>Bragg peak position, track curvature, energy deposition pattern → underutilized by cuts</a:t>
+            </a:r>
+          </a:p>
+          <a:p>
+            <a:pPr>
+              <a:spcAft>
+                <a:spcPts val="600"/>
+              </a:spcAft>
+              <a:defRPr sz="1600" b="1">
+                <a:solidFill>
+                  <a:srgbClr val="174994"/>
+                </a:solidFill>
+                <a:latin typeface="Times New Roman"/>
+              </a:defRPr>
+            </a:pPr>
+            <a:r>
+              <a:rPr lang="en-US" sz="2000" dirty="0"/>
+              <a:t>Our approach: CNNs on track images → the MATE-Automation pipeline</a:t>
+            </a:r>
+          </a:p>
+          <a:p>
+            <a:pPr lvl="1">
+              <a:spcAft>
+                <a:spcPts val="600"/>
+              </a:spcAft>
+              <a:defRPr sz="1600">
+                <a:solidFill>
+                  <a:srgbClr val="2D2D2D"/>
+                </a:solidFill>
+                <a:latin typeface="Times New Roman"/>
+              </a:defRPr>
+            </a:pPr>
+            <a:r>
+              <a:rPr lang="en-US" sz="2000" dirty="0"/>
+              <a:t>ResNet-18 backbone + CrossAttention fusion of physics features</a:t>
+            </a:r>
+          </a:p>
+        </p:txBody>
+      </p:sp>
+      <p:sp>
+        <p:nvSpPr>
           <p:cNvPr id="4" name="Rectangle 3"/>
           <p:cNvSpPr/>
           <p:nvPr/>
@@ -5521,244 +5716,10 @@
           </a:p>
         </p:txBody>
       </p:sp>
-      <p:sp>
-        <p:nvSpPr>
-          <p:cNvPr id="6" name="TextBox 5"/>
-          <p:cNvSpPr txBox="1"/>
-          <p:nvPr/>
-        </p:nvSpPr>
-        <p:spPr>
-          <a:xfrm>
-            <a:off x="640080" y="1234440"/>
-            <a:ext cx="6858000" cy="3816429"/>
-          </a:xfrm>
-          <a:prstGeom prst="rect">
-            <a:avLst/>
-          </a:prstGeom>
-          <a:noFill/>
-        </p:spPr>
-        <p:txBody>
-          <a:bodyPr wrap="square">
-            <a:spAutoFit/>
-          </a:bodyPr>
-          <a:lstStyle/>
-          <a:p>
-            <a:pPr>
-              <a:spcAft>
-                <a:spcPts val="600"/>
-              </a:spcAft>
-              <a:defRPr sz="1600" b="1">
-                <a:solidFill>
-                  <a:srgbClr val="174994"/>
-                </a:solidFill>
-                <a:latin typeface="Times New Roman"/>
-              </a:defRPr>
-            </a:pPr>
-            <a:r>
-              <a:rPr lang="en-US" dirty="0"/>
-              <a:t>Traditional methods struggle with TPC data</a:t>
-            </a:r>
-          </a:p>
-          <a:p>
-            <a:pPr lvl="1">
-              <a:spcAft>
-                <a:spcPts val="600"/>
-              </a:spcAft>
-              <a:defRPr sz="1600">
-                <a:solidFill>
-                  <a:srgbClr val="2D2D2D"/>
-                </a:solidFill>
-                <a:latin typeface="Times New Roman"/>
-              </a:defRPr>
-            </a:pPr>
-            <a:r>
-              <a:rPr lang="en-US" dirty="0"/>
-              <a:t>dE-E: overlapping distributions at similar A/Z (e.g., ³He/⁴He, ¹³C/¹⁴C)</a:t>
-            </a:r>
-          </a:p>
-          <a:p>
-            <a:pPr lvl="1">
-              <a:spcAft>
-                <a:spcPts val="600"/>
-              </a:spcAft>
-              <a:defRPr sz="1600">
-                <a:solidFill>
-                  <a:srgbClr val="2D2D2D"/>
-                </a:solidFill>
-                <a:latin typeface="Times New Roman"/>
-              </a:defRPr>
-            </a:pPr>
-            <a:r>
-              <a:rPr lang="en-US" dirty="0"/>
-              <a:t>Bragg-curve fitting: pile-up, dynamic range across beam vs. recoil region</a:t>
-            </a:r>
-          </a:p>
-          <a:p>
-            <a:pPr lvl="1">
-              <a:spcAft>
-                <a:spcPts val="600"/>
-              </a:spcAft>
-              <a:defRPr sz="1600">
-                <a:solidFill>
-                  <a:srgbClr val="2D2D2D"/>
-                </a:solidFill>
-                <a:latin typeface="Times New Roman"/>
-              </a:defRPr>
-            </a:pPr>
-            <a:r>
-              <a:rPr lang="en-US" dirty="0"/>
-              <a:t>Hough transform mislabels ~1.5% of events (NST-2025-0958)</a:t>
-            </a:r>
-          </a:p>
-          <a:p>
-            <a:pPr>
-              <a:spcAft>
-                <a:spcPts val="600"/>
-              </a:spcAft>
-              <a:defRPr sz="1600" b="1">
-                <a:solidFill>
-                  <a:srgbClr val="174994"/>
-                </a:solidFill>
-                <a:latin typeface="Times New Roman"/>
-              </a:defRPr>
-            </a:pPr>
-            <a:r>
-              <a:rPr lang="en-US" dirty="0"/>
-              <a:t>MATE-TPC at IMP (HIRFL-RIBLL)</a:t>
-            </a:r>
-          </a:p>
-          <a:p>
-            <a:pPr lvl="1">
-              <a:spcAft>
-                <a:spcPts val="600"/>
-              </a:spcAft>
-              <a:defRPr sz="1600">
-                <a:solidFill>
-                  <a:srgbClr val="2D2D2D"/>
-                </a:solidFill>
-                <a:latin typeface="Times New Roman"/>
-              </a:defRPr>
-            </a:pPr>
-            <a:r>
-              <a:rPr lang="en-US" dirty="0"/>
-              <a:t>GEM readout, 3,792 triangular pads (48×80), GET electronics</a:t>
-            </a:r>
-          </a:p>
-          <a:p>
-            <a:pPr lvl="1">
-              <a:spcAft>
-                <a:spcPts val="600"/>
-              </a:spcAft>
-              <a:defRPr sz="1600">
-                <a:solidFill>
-                  <a:srgbClr val="2D2D2D"/>
-                </a:solidFill>
-                <a:latin typeface="Times New Roman"/>
-              </a:defRPr>
-            </a:pPr>
-            <a:r>
-              <a:rPr lang="en-US" dirty="0"/>
-              <a:t>¹²C+¹²C commissioning data: elastic vs. fusion + 5 reaction channels</a:t>
-            </a:r>
-          </a:p>
-          <a:p>
-            <a:pPr>
-              <a:spcAft>
-                <a:spcPts val="600"/>
-              </a:spcAft>
-              <a:defRPr sz="1600" b="1">
-                <a:solidFill>
-                  <a:srgbClr val="174994"/>
-                </a:solidFill>
-                <a:latin typeface="Times New Roman"/>
-              </a:defRPr>
-            </a:pPr>
-            <a:r>
-              <a:rPr lang="en-US" dirty="0"/>
-              <a:t>Key insight: 2D track images encode species-specific spatial signatures</a:t>
-            </a:r>
-          </a:p>
-          <a:p>
-            <a:pPr lvl="1">
-              <a:spcAft>
-                <a:spcPts val="600"/>
-              </a:spcAft>
-              <a:defRPr sz="1600">
-                <a:solidFill>
-                  <a:srgbClr val="2D2D2D"/>
-                </a:solidFill>
-                <a:latin typeface="Times New Roman"/>
-              </a:defRPr>
-            </a:pPr>
-            <a:r>
-              <a:rPr lang="en-US" dirty="0"/>
-              <a:t>Bragg peak position, track curvature, energy deposition pattern → underutilized by cuts</a:t>
-            </a:r>
-          </a:p>
-          <a:p>
-            <a:pPr>
-              <a:spcAft>
-                <a:spcPts val="600"/>
-              </a:spcAft>
-              <a:defRPr sz="1600" b="1">
-                <a:solidFill>
-                  <a:srgbClr val="174994"/>
-                </a:solidFill>
-                <a:latin typeface="Times New Roman"/>
-              </a:defRPr>
-            </a:pPr>
-            <a:r>
-              <a:rPr lang="en-US" dirty="0"/>
-              <a:t>Our approach: CNNs on track images → the MATE-Automation pipeline</a:t>
-            </a:r>
-          </a:p>
-          <a:p>
-            <a:pPr lvl="1">
-              <a:spcAft>
-                <a:spcPts val="600"/>
-              </a:spcAft>
-              <a:defRPr sz="1600">
-                <a:solidFill>
-                  <a:srgbClr val="2D2D2D"/>
-                </a:solidFill>
-                <a:latin typeface="Times New Roman"/>
-              </a:defRPr>
-            </a:pPr>
-            <a:r>
-              <a:rPr lang="en-US" dirty="0"/>
-              <a:t>ResNet-18 backbone + CrossAttention fusion of physics features</a:t>
-            </a:r>
-          </a:p>
-        </p:txBody>
-      </p:sp>
-      <p:pic>
-        <p:nvPicPr>
-          <p:cNvPr id="7" name="Picture 6" descr="_page_5_Figure_3.jpeg"/>
-          <p:cNvPicPr>
-            <a:picLocks noChangeAspect="1"/>
-          </p:cNvPicPr>
-          <p:nvPr/>
-        </p:nvPicPr>
-        <p:blipFill>
-          <a:blip r:embed="rId3"/>
-          <a:stretch>
-            <a:fillRect/>
-          </a:stretch>
-        </p:blipFill>
-        <p:spPr>
-          <a:xfrm>
-            <a:off x="7589520" y="1234440"/>
-            <a:ext cx="4086982" cy="4389120"/>
-          </a:xfrm>
-          <a:prstGeom prst="rect">
-            <a:avLst/>
-          </a:prstGeom>
-        </p:spPr>
-      </p:pic>
     </p:spTree>
     <p:extLst>
       <p:ext uri="{BB962C8B-B14F-4D97-AF65-F5344CB8AC3E}">
-        <p14:creationId xmlns:p14="http://schemas.microsoft.com/office/powerpoint/2010/main" val="2405765459"/>
+        <p14:creationId xmlns:p14="http://schemas.microsoft.com/office/powerpoint/2010/main" val="3404036522"/>
       </p:ext>
     </p:extLst>
   </p:cSld>
@@ -7094,38 +7055,38 @@
 </file>
 
 <file path=ppt/theme/theme1.xml><?xml version="1.0" encoding="utf-8"?>
-<a:theme xmlns:a="http://schemas.openxmlformats.org/drawingml/2006/main" name="Office Theme">
+<a:theme xmlns:a="http://schemas.openxmlformats.org/drawingml/2006/main" name="Office Theme [1775995293779]">
   <a:themeElements>
     <a:clrScheme name="Office">
       <a:dk1>
-        <a:sysClr val="windowText" lastClr="000000"/>
+        <a:srgbClr val="000000"/>
       </a:dk1>
       <a:lt1>
-        <a:sysClr val="window" lastClr="FFFFFF"/>
+        <a:srgbClr val="FFFFFF"/>
       </a:lt1>
       <a:dk2>
-        <a:srgbClr val="1F497D"/>
+        <a:srgbClr val="44546A"/>
       </a:dk2>
       <a:lt2>
-        <a:srgbClr val="EEECE1"/>
+        <a:srgbClr val="E7E6E6"/>
       </a:lt2>
       <a:accent1>
-        <a:srgbClr val="4F81BD"/>
+        <a:srgbClr val="4472C4"/>
       </a:accent1>
       <a:accent2>
-        <a:srgbClr val="C0504D"/>
+        <a:srgbClr val="ED7D31"/>
       </a:accent2>
       <a:accent3>
-        <a:srgbClr val="9BBB59"/>
+        <a:srgbClr val="A5A5A5"/>
       </a:accent3>
       <a:accent4>
-        <a:srgbClr val="8064A2"/>
+        <a:srgbClr val="FFC000"/>
       </a:accent4>
       <a:accent5>
-        <a:srgbClr val="4BACC6"/>
+        <a:srgbClr val="5B9BD5"/>
       </a:accent5>
       <a:accent6>
-        <a:srgbClr val="F79646"/>
+        <a:srgbClr val="70AD47"/>
       </a:accent6>
       <a:hlink>
         <a:srgbClr val="0000FF"/>
@@ -7136,7 +7097,7 @@
     </a:clrScheme>
     <a:fontScheme name="Office">
       <a:majorFont>
-        <a:latin typeface="Calibri"/>
+        <a:latin typeface="Calibri Light"/>
         <a:ea typeface=""/>
         <a:cs typeface=""/>
         <a:font script="Jpan" typeface="ＭＳ Ｐゴシック"/>
@@ -7710,7 +7671,7 @@
 
 <file path=ppt/webextensions/taskpanes.xml><?xml version="1.0" encoding="utf-8"?>
 <wetp:taskpanes xmlns:wetp="http://schemas.microsoft.com/office/webextensions/taskpanes/2010/11">
-  <wetp:taskpane dockstate="right" visibility="0" width="662" row="9">
+  <wetp:taskpane dockstate="right" visibility="0" width="470" row="9">
     <wetp:webextensionref xmlns:r="http://schemas.openxmlformats.org/officeDocument/2006/relationships" r:id="rId1"/>
   </wetp:taskpane>
 </wetp:taskpanes>

</xml_diff>